<commit_message>
Nicht verlangte Uebungen entfernt (Testlevels in KN03, Deployment in KN06)
Laut Miro-Board sind nur unit-testing/UEBUNGEN.md und ci-cd-pipeline/UEBUNGEN.md verlinkt.
</commit_message>
<xml_diff>
--- a/KN03/praesentation/KN03.pptx
+++ b/KN03/praesentation/KN03.pptx
@@ -11,10 +11,9 @@
     <p:sldId id="259" r:id="rId5"/>
     <p:sldId id="260" r:id="rId6"/>
     <p:sldId id="261" r:id="rId7"/>
-    <p:sldId id="262" r:id="rId8"/>
   </p:sldIdLst>
   <p:notesMasterIdLst>
-    <p:notesMasterId r:id="rId9"/>
+    <p:notesMasterId r:id="rId8"/>
   </p:notesMasterIdLst>
   <p:sldSz cx="9144000" cy="5143500"/>
   <p:notesSz cx="5143500" cy="9144000"/>
@@ -113,27 +112,22 @@
   <p:extLst>
     <p:ext uri="{521415D9-36F7-43E2-AB2F-B90AF26B5E84}">
       <p14:sectionLst xmlns:p14="http://schemas.microsoft.com/office/powerpoint/2010/main">
-        <p14:section name="Einstieg" id="{2b28a70d-79f0-61ad-1827-ac956d6fcb32}">
+        <p14:section name="Einstieg" id="{1aa8fab2-2faa-6a55-ece4-634d3937729e}">
           <p14:sldIdLst>
             <p14:sldId id="256"/>
           </p14:sldIdLst>
         </p14:section>
-        <p14:section name="Testlevels" id="{b7530bcf-d0f1-b8cb-4564-3992c80a9415}">
+        <p14:section name="Unit Testing" id="{e3831544-24d0-3eb6-ae50-b3c770faebf9}">
           <p14:sldIdLst>
             <p14:sldId id="257"/>
-          </p14:sldIdLst>
-        </p14:section>
-        <p14:section name="Unit Testing" id="{5f55d6c9-fe48-ff46-95bd-72e0ce85cbd7}">
-          <p14:sldIdLst>
             <p14:sldId id="258"/>
             <p14:sldId id="259"/>
             <p14:sldId id="260"/>
-            <p14:sldId id="261"/>
           </p14:sldIdLst>
         </p14:section>
-        <p14:section name="Fazit" id="{48f0cf3a-c68a-9483-3d42-f882c01b2dd1}">
+        <p14:section name="Fazit" id="{a9ebb01f-604a-30cd-e9b9-9967d81f9d4f}">
           <p14:sldIdLst>
-            <p14:sldId id="262"/>
+            <p14:sldId id="261"/>
           </p14:sldIdLst>
         </p14:section>
       </p14:sectionLst>
@@ -540,7 +534,7 @@
           <a:p>
             <a:r>
               <a:rPr lang="en-US" dirty="0"/>
-              <a:t>KN03 hat zwei Teile: die Testlevels und Unit Testing mit JUnit 5. Dazu habe ich einen Rechner getestet und Tests für die Bank-Simulation geschrieben.</a:t>
+              <a:t>In KN03 geht es um Unit Testing mit JUnit 5. Ich habe einen Rechner getestet, die JUnit-Features zusammengefasst und Tests für die Bank-Simulation geschrieben.</a:t>
             </a:r>
             <a:endParaRPr lang="en-US" dirty="0"/>
           </a:p>
@@ -628,7 +622,7 @@
           <a:p>
             <a:r>
               <a:rPr lang="en-US" dirty="0"/>
-              <a:t>Die Testlevels bauen aufeinander auf. Unit- und Component-Tests schreibt der Entwickler, sie sind schnell und laufen bei jedem Build. Je weiter rechts, desto langsamer und desto mehr wird die Software als Ganzes getestet.</a:t>
+              <a:t>Für den Calculator habe ich 14 Tests geschrieben. BeforeEach erstellt vor jedem Test einen neuen Rechner. Mit assertThrows prüfe ich die Division durch null und mit einem parametrisierten Test mehrere Werte auf einmal. Ausführen geht in IntelliJ oder mit mvn test.</a:t>
             </a:r>
             <a:endParaRPr lang="en-US" dirty="0"/>
           </a:p>
@@ -716,7 +710,7 @@
           <a:p>
             <a:r>
               <a:rPr lang="en-US" dirty="0"/>
-              <a:t>Für den Calculator habe ich 14 Tests geschrieben. BeforeEach erstellt vor jedem Test einen neuen Rechner. Mit assertThrows prüfe ich die Division durch null und mit einem parametrisierten Test mehrere Werte auf einmal. Ausführen geht in IntelliJ oder mit mvn test.</a:t>
+              <a:t>Die wichtigsten Annotations und Assertions im Überblick. Die ausführliche Zusammenfassung ist im Markdown-Dokument im Repository.</a:t>
             </a:r>
             <a:endParaRPr lang="en-US" dirty="0"/>
           </a:p>
@@ -804,7 +798,7 @@
           <a:p>
             <a:r>
               <a:rPr lang="en-US" dirty="0"/>
-              <a:t>Die wichtigsten Annotations und Assertions im Überblick. Die ausführliche Zusammenfassung ist im Markdown-Dokument im Repository.</a:t>
+              <a:t>Die Bank speichert alle Konten in einer TreeMap. Es gibt drei Kontoarten: das Sparkonto darf nicht ins Minus, das Jugendsparkonto gibt 1 Prozent Bonus und das Lohnkonto hat eine Kreditlimite. Beträge sind in Millirappen, damit es keine Rundungsfehler gibt.</a:t>
             </a:r>
             <a:endParaRPr lang="en-US" dirty="0"/>
           </a:p>
@@ -892,7 +886,7 @@
           <a:p>
             <a:r>
               <a:rPr lang="en-US" dirty="0"/>
-              <a:t>Die Bank speichert alle Konten in einer TreeMap. Es gibt drei Kontoarten: das Sparkonto darf nicht ins Minus, das Jugendsparkonto gibt 1 Prozent Bonus und das Lohnkonto hat eine Kreditlimite. Beträge sind in Millirappen, damit es keine Rundungsfehler gibt.</a:t>
+              <a:t>Für die Bank habe ich 40 Tests geschrieben. Alle Klassen ausser Main haben über 90 Prozent Abdeckung. Bei den print-Methoden leite ich System.out in einen Stream um, damit ich prüfen kann, was gedruckt wurde.</a:t>
             </a:r>
             <a:endParaRPr lang="en-US" dirty="0"/>
           </a:p>
@@ -980,7 +974,7 @@
           <a:p>
             <a:r>
               <a:rPr lang="en-US" dirty="0"/>
-              <a:t>Für die Bank habe ich 40 Tests geschrieben. Alle Klassen ausser Main haben über 90 Prozent Abdeckung. Bei den print-Methoden leite ich System.out in einen Stream um, damit ich prüfen kann, was gedruckt wurde.</a:t>
+              <a:t>Fazit: Unit-Tests sind die Basis der Testpyramide. Sie laufen in Sekunden, und mit dem JaCoCo-Report sieht man genau, welcher Code noch nicht getestet ist.</a:t>
             </a:r>
             <a:endParaRPr lang="en-US" dirty="0"/>
           </a:p>
@@ -1004,94 +998,6 @@
             <a:fld id="{F7021451-1387-4CA6-816F-3879F97B5CBC}" type="slidenum">
               <a:rPr lang="en-US"/>
               <a:t>6</a:t>
-            </a:fld>
-            <a:endParaRPr lang="en-US"/>
-          </a:p>
-        </p:txBody>
-      </p:sp>
-    </p:spTree>
-    <p:extLst>
-      <p:ext uri="{BB962C8B-B14F-4D97-AF65-F5344CB8AC3E}">
-        <p14:creationId xmlns:p14="http://schemas.microsoft.com/office/powerpoint/2010/main" val="1024086991"/>
-      </p:ext>
-    </p:extLst>
-  </p:cSld>
-  <p:clrMapOvr>
-    <a:masterClrMapping/>
-  </p:clrMapOvr>
-</p:notes>
-</file>
-
-<file path=ppt/notesSlides/notesSlide7.xml><?xml version="1.0" encoding="utf-8"?>
-<p:notes xmlns:a="http://schemas.openxmlformats.org/drawingml/2006/main" xmlns:r="http://schemas.openxmlformats.org/officeDocument/2006/relationships" xmlns:p="http://schemas.openxmlformats.org/presentationml/2006/main">
-  <p:cSld>
-    <p:spTree>
-      <p:nvGrpSpPr>
-        <p:cNvPr id="1" name=""/>
-        <p:cNvGrpSpPr/>
-        <p:nvPr/>
-      </p:nvGrpSpPr>
-      <p:grpSpPr>
-        <a:xfrm>
-          <a:off x="0" y="0"/>
-          <a:ext cx="0" cy="0"/>
-          <a:chOff x="0" y="0"/>
-          <a:chExt cx="0" cy="0"/>
-        </a:xfrm>
-      </p:grpSpPr>
-      <p:sp>
-        <p:nvSpPr>
-          <p:cNvPr id="2" name="Slide Image Placeholder 1"/>
-          <p:cNvSpPr>
-            <a:spLocks noGrp="1" noRot="1" noChangeAspect="1"/>
-          </p:cNvSpPr>
-          <p:nvPr>
-            <p:ph type="sldImg"/>
-          </p:nvPr>
-        </p:nvSpPr>
-        <p:spPr/>
-      </p:sp>
-      <p:sp>
-        <p:nvSpPr>
-          <p:cNvPr id="3" name="Notes Placeholder 2"/>
-          <p:cNvSpPr>
-            <a:spLocks noGrp="1"/>
-          </p:cNvSpPr>
-          <p:nvPr>
-            <p:ph type="body" idx="1"/>
-          </p:nvPr>
-        </p:nvSpPr>
-        <p:spPr/>
-        <p:txBody>
-          <a:bodyPr/>
-          <a:lstStyle/>
-          <a:p>
-            <a:r>
-              <a:rPr lang="en-US" dirty="0"/>
-              <a:t>Fazit: Unit-Tests sind die Basis der Testpyramide. Sie laufen in Sekunden, und mit dem JaCoCo-Report sieht man genau, welcher Code noch nicht getestet ist.</a:t>
-            </a:r>
-            <a:endParaRPr lang="en-US" dirty="0"/>
-          </a:p>
-        </p:txBody>
-      </p:sp>
-      <p:sp>
-        <p:nvSpPr>
-          <p:cNvPr id="4" name="Slide Number Placeholder 3"/>
-          <p:cNvSpPr>
-            <a:spLocks noGrp="1"/>
-          </p:cNvSpPr>
-          <p:nvPr>
-            <p:ph type="sldNum" sz="quarter" idx="10"/>
-          </p:nvPr>
-        </p:nvSpPr>
-        <p:spPr/>
-        <p:txBody>
-          <a:bodyPr/>
-          <a:lstStyle/>
-          <a:p>
-            <a:fld id="{F7021451-1387-4CA6-816F-3879F97B5CBC}" type="slidenum">
-              <a:rPr lang="en-US"/>
-              <a:t>7</a:t>
             </a:fld>
             <a:endParaRPr lang="en-US"/>
           </a:p>
@@ -1935,7 +1841,7 @@
                   <a:schemeClr val="bg1"/>
                 </a:solidFill>
               </a:rPr>
-              <a:t>Von Unit bis Acceptance, JUnit 5 und Tests für die Bank-Simulation</a:t>
+              <a:t>JUnit 5, ein Rechner und Tests für die Bank-Simulation</a:t>
             </a:r>
             <a:endParaRPr lang="en-US" sz="1800" dirty="0"/>
           </a:p>
@@ -2062,7 +1968,7 @@
                 <a:ea typeface="Cambria" pitchFamily="34" charset="-122"/>
                 <a:cs typeface="Cambria" pitchFamily="34" charset="-120"/>
               </a:rPr>
-              <a:t>Die Testlevels</a:t>
+              <a:t>Aufgabe 1: Calculator mit JUnit 5</a:t>
             </a:r>
             <a:endParaRPr lang="en-US" sz="2800" dirty="0"/>
           </a:p>
@@ -2070,22 +1976,26 @@
       </p:sp>
       <p:sp>
         <p:nvSpPr>
-          <p:cNvPr id="4" name="Verbindung"/>
+          <p:cNvPr id="4" name="Code Box"/>
           <p:cNvSpPr/>
           <p:nvPr/>
         </p:nvSpPr>
         <p:spPr>
           <a:xfrm>
-            <a:off x="1280160" y="1691640"/>
-            <a:ext cx="6583680" cy="0"/>
-          </a:xfrm>
-          <a:prstGeom prst="line">
-            <a:avLst/>
-          </a:prstGeom>
-          <a:noFill/>
-          <a:ln w="38100">
+            <a:off x="457200" y="1097280"/>
+            <a:ext cx="5120640" cy="3383280"/>
+          </a:xfrm>
+          <a:prstGeom prst="roundRect">
+            <a:avLst>
+              <a:gd name="adj" fmla="val 2162"/>
+            </a:avLst>
+          </a:prstGeom>
+          <a:solidFill>
+            <a:schemeClr val="tx1"/>
+          </a:solidFill>
+          <a:ln w="12700">
             <a:solidFill>
-              <a:schemeClr val="accent6"/>
+              <a:schemeClr val="tx1"/>
             </a:solidFill>
             <a:prstDash val="solid"/>
           </a:ln>
@@ -2093,24 +2003,243 @@
       </p:sp>
       <p:sp>
         <p:nvSpPr>
-          <p:cNvPr id="5" name="Schritt Unit"/>
+          <p:cNvPr id="5" name="Text 2"/>
+          <p:cNvSpPr txBox="1"/>
+          <p:nvPr/>
+        </p:nvSpPr>
+        <p:spPr>
+          <a:xfrm>
+            <a:off x="640080" y="1207008"/>
+            <a:ext cx="4754880" cy="274320"/>
+          </a:xfrm>
+          <a:prstGeom prst="rect">
+            <a:avLst/>
+          </a:prstGeom>
+          <a:noFill/>
+          <a:ln/>
+        </p:spPr>
+        <p:txBody>
+          <a:bodyPr wrap="square" lIns="0" tIns="0" rIns="0" bIns="0" rtlCol="0" anchor="ctr"/>
+          <a:lstStyle/>
+          <a:p>
+            <a:pPr indent="0" marL="0">
+              <a:buNone/>
+            </a:pPr>
+            <a:r>
+              <a:rPr lang="en-US" sz="1100" b="1" dirty="0">
+                <a:solidFill>
+                  <a:schemeClr val="accent6"/>
+                </a:solidFill>
+              </a:rPr>
+              <a:t>CalculatorTest.java</a:t>
+            </a:r>
+            <a:endParaRPr lang="en-US" sz="1100" dirty="0"/>
+          </a:p>
+        </p:txBody>
+      </p:sp>
+      <p:sp>
+        <p:nvSpPr>
+          <p:cNvPr id="6" name="Code"/>
+          <p:cNvSpPr txBox="1"/>
+          <p:nvPr/>
+        </p:nvSpPr>
+        <p:spPr>
+          <a:xfrm>
+            <a:off x="640080" y="1508760"/>
+            <a:ext cx="4754880" cy="2834640"/>
+          </a:xfrm>
+          <a:prstGeom prst="rect">
+            <a:avLst/>
+          </a:prstGeom>
+          <a:noFill/>
+          <a:ln/>
+        </p:spPr>
+        <p:txBody>
+          <a:bodyPr wrap="square" lIns="0" tIns="0" rIns="0" bIns="0" rtlCol="0" anchor="t"/>
+          <a:lstStyle/>
+          <a:p>
+            <a:pPr indent="0" marL="0">
+              <a:buNone/>
+            </a:pPr>
+            <a:r>
+              <a:rPr lang="en-US" sz="1200" dirty="0">
+                <a:solidFill>
+                  <a:schemeClr val="bg1"/>
+                </a:solidFill>
+                <a:latin typeface="Courier New" pitchFamily="34" charset="0"/>
+                <a:ea typeface="Courier New" pitchFamily="34" charset="-122"/>
+                <a:cs typeface="Courier New" pitchFamily="34" charset="-120"/>
+              </a:rPr>
+              <a:t>@BeforeEach</a:t>
+            </a:r>
+            <a:endParaRPr lang="en-US" sz="1200" dirty="0"/>
+          </a:p>
+          <a:p>
+            <a:pPr indent="0" marL="0">
+              <a:buNone/>
+            </a:pPr>
+            <a:r>
+              <a:rPr lang="en-US" sz="1200" dirty="0">
+                <a:solidFill>
+                  <a:schemeClr val="bg1"/>
+                </a:solidFill>
+                <a:latin typeface="Courier New" pitchFamily="34" charset="0"/>
+                <a:ea typeface="Courier New" pitchFamily="34" charset="-122"/>
+                <a:cs typeface="Courier New" pitchFamily="34" charset="-120"/>
+              </a:rPr>
+              <a:t>void setUp() {</a:t>
+            </a:r>
+            <a:endParaRPr lang="en-US" sz="1200" dirty="0"/>
+          </a:p>
+          <a:p>
+            <a:pPr indent="0" marL="0">
+              <a:buNone/>
+            </a:pPr>
+            <a:r>
+              <a:rPr lang="en-US" sz="1200" dirty="0">
+                <a:solidFill>
+                  <a:schemeClr val="bg1"/>
+                </a:solidFill>
+                <a:latin typeface="Courier New" pitchFamily="34" charset="0"/>
+                <a:ea typeface="Courier New" pitchFamily="34" charset="-122"/>
+                <a:cs typeface="Courier New" pitchFamily="34" charset="-120"/>
+              </a:rPr>
+              <a:t>    calculator = new Calculator();</a:t>
+            </a:r>
+            <a:endParaRPr lang="en-US" sz="1200" dirty="0"/>
+          </a:p>
+          <a:p>
+            <a:pPr indent="0" marL="0">
+              <a:buNone/>
+            </a:pPr>
+            <a:r>
+              <a:rPr lang="en-US" sz="1200" dirty="0">
+                <a:solidFill>
+                  <a:schemeClr val="bg1"/>
+                </a:solidFill>
+                <a:latin typeface="Courier New" pitchFamily="34" charset="0"/>
+                <a:ea typeface="Courier New" pitchFamily="34" charset="-122"/>
+                <a:cs typeface="Courier New" pitchFamily="34" charset="-120"/>
+              </a:rPr>
+              <a:t>}</a:t>
+            </a:r>
+            <a:endParaRPr lang="en-US" sz="1200" dirty="0"/>
+          </a:p>
+          <a:p>
+            <a:pPr indent="0" marL="0">
+              <a:buNone/>
+            </a:pPr>
+            <a:endParaRPr lang="en-US" sz="1200" dirty="0"/>
+          </a:p>
+          <a:p>
+            <a:pPr indent="0" marL="0">
+              <a:buNone/>
+            </a:pPr>
+            <a:r>
+              <a:rPr lang="en-US" sz="1200" dirty="0">
+                <a:solidFill>
+                  <a:schemeClr val="bg1"/>
+                </a:solidFill>
+                <a:latin typeface="Courier New" pitchFamily="34" charset="0"/>
+                <a:ea typeface="Courier New" pitchFamily="34" charset="-122"/>
+                <a:cs typeface="Courier New" pitchFamily="34" charset="-120"/>
+              </a:rPr>
+              <a:t>@Test</a:t>
+            </a:r>
+            <a:endParaRPr lang="en-US" sz="1200" dirty="0"/>
+          </a:p>
+          <a:p>
+            <a:pPr indent="0" marL="0">
+              <a:buNone/>
+            </a:pPr>
+            <a:r>
+              <a:rPr lang="en-US" sz="1200" dirty="0">
+                <a:solidFill>
+                  <a:schemeClr val="bg1"/>
+                </a:solidFill>
+                <a:latin typeface="Courier New" pitchFamily="34" charset="0"/>
+                <a:ea typeface="Courier New" pitchFamily="34" charset="-122"/>
+                <a:cs typeface="Courier New" pitchFamily="34" charset="-120"/>
+              </a:rPr>
+              <a:t>void divideByZeroThrowsException() {</a:t>
+            </a:r>
+            <a:endParaRPr lang="en-US" sz="1200" dirty="0"/>
+          </a:p>
+          <a:p>
+            <a:pPr indent="0" marL="0">
+              <a:buNone/>
+            </a:pPr>
+            <a:r>
+              <a:rPr lang="en-US" sz="1200" dirty="0">
+                <a:solidFill>
+                  <a:schemeClr val="bg1"/>
+                </a:solidFill>
+                <a:latin typeface="Courier New" pitchFamily="34" charset="0"/>
+                <a:ea typeface="Courier New" pitchFamily="34" charset="-122"/>
+                <a:cs typeface="Courier New" pitchFamily="34" charset="-120"/>
+              </a:rPr>
+              <a:t>    assertThrows(ArithmeticException.class,</a:t>
+            </a:r>
+            <a:endParaRPr lang="en-US" sz="1200" dirty="0"/>
+          </a:p>
+          <a:p>
+            <a:pPr indent="0" marL="0">
+              <a:buNone/>
+            </a:pPr>
+            <a:r>
+              <a:rPr lang="en-US" sz="1200" dirty="0">
+                <a:solidFill>
+                  <a:schemeClr val="bg1"/>
+                </a:solidFill>
+                <a:latin typeface="Courier New" pitchFamily="34" charset="0"/>
+                <a:ea typeface="Courier New" pitchFamily="34" charset="-122"/>
+                <a:cs typeface="Courier New" pitchFamily="34" charset="-120"/>
+              </a:rPr>
+              <a:t>        () -&gt; calculator.divide(5, 0));</a:t>
+            </a:r>
+            <a:endParaRPr lang="en-US" sz="1200" dirty="0"/>
+          </a:p>
+          <a:p>
+            <a:pPr indent="0" marL="0">
+              <a:buNone/>
+            </a:pPr>
+            <a:r>
+              <a:rPr lang="en-US" sz="1200" dirty="0">
+                <a:solidFill>
+                  <a:schemeClr val="bg1"/>
+                </a:solidFill>
+                <a:latin typeface="Courier New" pitchFamily="34" charset="0"/>
+                <a:ea typeface="Courier New" pitchFamily="34" charset="-122"/>
+                <a:cs typeface="Courier New" pitchFamily="34" charset="-120"/>
+              </a:rPr>
+              <a:t>}</a:t>
+            </a:r>
+            <a:endParaRPr lang="en-US" sz="1200" dirty="0"/>
+          </a:p>
+        </p:txBody>
+      </p:sp>
+      <p:sp>
+        <p:nvSpPr>
+          <p:cNvPr id="7" name="Kennzahl Tests grün"/>
           <p:cNvSpPr/>
           <p:nvPr/>
         </p:nvSpPr>
         <p:spPr>
           <a:xfrm>
-            <a:off x="960120" y="1371600"/>
-            <a:ext cx="640080" cy="640080"/>
-          </a:xfrm>
-          <a:prstGeom prst="ellipse">
-            <a:avLst/>
+            <a:off x="5852160" y="1097280"/>
+            <a:ext cx="2834640" cy="1554480"/>
+          </a:xfrm>
+          <a:prstGeom prst="roundRect">
+            <a:avLst>
+              <a:gd name="adj" fmla="val 4706"/>
+            </a:avLst>
           </a:prstGeom>
           <a:solidFill>
-            <a:schemeClr val="accent3"/>
+            <a:schemeClr val="bg2"/>
           </a:solidFill>
-          <a:ln w="38100">
+          <a:ln w="12700">
             <a:solidFill>
-              <a:schemeClr val="bg1"/>
+              <a:schemeClr val="bg2"/>
             </a:solidFill>
             <a:prstDash val="solid"/>
           </a:ln>
@@ -2118,86 +2247,14 @@
       </p:sp>
       <p:sp>
         <p:nvSpPr>
-          <p:cNvPr id="6" name="Text 3"/>
-          <p:cNvSpPr txBox="1"/>
-          <p:nvPr/>
-        </p:nvSpPr>
-        <p:spPr>
-          <a:xfrm>
-            <a:off x="960120" y="1371600"/>
-            <a:ext cx="640080" cy="640080"/>
-          </a:xfrm>
-          <a:prstGeom prst="rect">
-            <a:avLst/>
-          </a:prstGeom>
-          <a:noFill/>
-          <a:ln/>
-        </p:spPr>
-        <p:txBody>
-          <a:bodyPr wrap="square" lIns="0" tIns="0" rIns="0" bIns="0" rtlCol="0" anchor="ctr"/>
-          <a:lstStyle/>
-          <a:p>
-            <a:pPr algn="ctr" indent="0" marL="0">
-              <a:buNone/>
-            </a:pPr>
-            <a:r>
-              <a:rPr lang="en-US" sz="1800" b="1" dirty="0">
-                <a:solidFill>
-                  <a:schemeClr val="bg1"/>
-                </a:solidFill>
-              </a:rPr>
-              <a:t>1</a:t>
-            </a:r>
-            <a:endParaRPr lang="en-US" sz="1800" dirty="0"/>
-          </a:p>
-        </p:txBody>
-      </p:sp>
-      <p:sp>
-        <p:nvSpPr>
-          <p:cNvPr id="7" name="Text 4"/>
-          <p:cNvSpPr txBox="1"/>
-          <p:nvPr/>
-        </p:nvSpPr>
-        <p:spPr>
-          <a:xfrm>
-            <a:off x="502920" y="2148840"/>
-            <a:ext cx="1554480" cy="411480"/>
-          </a:xfrm>
-          <a:prstGeom prst="rect">
-            <a:avLst/>
-          </a:prstGeom>
-          <a:noFill/>
-          <a:ln/>
-        </p:spPr>
-        <p:txBody>
-          <a:bodyPr wrap="square" lIns="0" tIns="0" rIns="0" bIns="0" rtlCol="0" anchor="t"/>
-          <a:lstStyle/>
-          <a:p>
-            <a:pPr algn="ctr" indent="0" marL="0">
-              <a:buNone/>
-            </a:pPr>
-            <a:r>
-              <a:rPr lang="en-US" sz="1500" b="1" dirty="0">
-                <a:solidFill>
-                  <a:schemeClr val="tx2"/>
-                </a:solidFill>
-              </a:rPr>
-              <a:t>Unit</a:t>
-            </a:r>
-            <a:endParaRPr lang="en-US" sz="1500" dirty="0"/>
-          </a:p>
-        </p:txBody>
-      </p:sp>
-      <p:sp>
-        <p:nvSpPr>
           <p:cNvPr id="8" name="Text 5"/>
           <p:cNvSpPr txBox="1"/>
           <p:nvPr/>
         </p:nvSpPr>
         <p:spPr>
           <a:xfrm>
-            <a:off x="530352" y="2560320"/>
-            <a:ext cx="1499616" cy="1737360"/>
+            <a:off x="5852160" y="1280160"/>
+            <a:ext cx="2834640" cy="777240"/>
           </a:xfrm>
           <a:prstGeom prst="rect">
             <a:avLst/>
@@ -2206,6 +2263,45 @@
           <a:ln/>
         </p:spPr>
         <p:txBody>
+          <a:bodyPr wrap="square" lIns="0" tIns="0" rIns="0" bIns="0" rtlCol="0" anchor="ctr"/>
+          <a:lstStyle/>
+          <a:p>
+            <a:pPr algn="ctr" indent="0" marL="0">
+              <a:buNone/>
+            </a:pPr>
+            <a:r>
+              <a:rPr lang="en-US" sz="3600" b="1" dirty="0">
+                <a:solidFill>
+                  <a:schemeClr val="accent1"/>
+                </a:solidFill>
+                <a:latin typeface="Cambria" pitchFamily="34" charset="0"/>
+                <a:ea typeface="Cambria" pitchFamily="34" charset="-122"/>
+                <a:cs typeface="Cambria" pitchFamily="34" charset="-120"/>
+              </a:rPr>
+              <a:t>14</a:t>
+            </a:r>
+            <a:endParaRPr lang="en-US" sz="3600" dirty="0"/>
+          </a:p>
+        </p:txBody>
+      </p:sp>
+      <p:sp>
+        <p:nvSpPr>
+          <p:cNvPr id="9" name="Text 6"/>
+          <p:cNvSpPr txBox="1"/>
+          <p:nvPr/>
+        </p:nvSpPr>
+        <p:spPr>
+          <a:xfrm>
+            <a:off x="5943600" y="2057400"/>
+            <a:ext cx="2651760" cy="457200"/>
+          </a:xfrm>
+          <a:prstGeom prst="rect">
+            <a:avLst/>
+          </a:prstGeom>
+          <a:noFill/>
+          <a:ln/>
+        </p:spPr>
+        <p:txBody>
           <a:bodyPr wrap="square" lIns="0" tIns="0" rIns="0" bIns="0" rtlCol="0" anchor="t"/>
           <a:lstStyle/>
           <a:p>
@@ -2213,41 +2309,16 @@
               <a:buNone/>
             </a:pPr>
             <a:r>
-              <a:rPr lang="en-US" sz="1300" dirty="0">
+              <a:rPr lang="en-US" sz="1200" dirty="0">
                 <a:solidFill>
                   <a:schemeClr val="tx1"/>
                 </a:solidFill>
               </a:rPr>
-              <a:t>Einzelne Klasse, White-Box, Entwickler</a:t>
-            </a:r>
-            <a:endParaRPr lang="en-US" sz="1300" dirty="0"/>
-          </a:p>
-        </p:txBody>
-      </p:sp>
-      <p:sp>
-        <p:nvSpPr>
-          <p:cNvPr id="9" name="Schritt Component"/>
-          <p:cNvSpPr/>
-          <p:nvPr/>
-        </p:nvSpPr>
-        <p:spPr>
-          <a:xfrm>
-            <a:off x="2606040" y="1371600"/>
-            <a:ext cx="640080" cy="640080"/>
-          </a:xfrm>
-          <a:prstGeom prst="ellipse">
-            <a:avLst/>
-          </a:prstGeom>
-          <a:solidFill>
-            <a:schemeClr val="accent3"/>
-          </a:solidFill>
-          <a:ln w="38100">
-            <a:solidFill>
-              <a:schemeClr val="bg1"/>
-            </a:solidFill>
-            <a:prstDash val="solid"/>
-          </a:ln>
-        </p:spPr>
+              <a:t>Tests grün</a:t>
+            </a:r>
+            <a:endParaRPr lang="en-US" sz="1200" dirty="0"/>
+          </a:p>
+        </p:txBody>
       </p:sp>
       <p:sp>
         <p:nvSpPr>
@@ -2257,8 +2328,8 @@
         </p:nvSpPr>
         <p:spPr>
           <a:xfrm>
-            <a:off x="2606040" y="1371600"/>
-            <a:ext cx="640080" cy="640080"/>
+            <a:off x="5943600" y="2926080"/>
+            <a:ext cx="2743200" cy="1280160"/>
           </a:xfrm>
           <a:prstGeom prst="rect">
             <a:avLst/>
@@ -2267,528 +2338,43 @@
           <a:ln/>
         </p:spPr>
         <p:txBody>
-          <a:bodyPr wrap="square" lIns="0" tIns="0" rIns="0" bIns="0" rtlCol="0" anchor="ctr"/>
-          <a:lstStyle/>
-          <a:p>
-            <a:pPr algn="ctr" indent="0" marL="0">
-              <a:buNone/>
-            </a:pPr>
-            <a:r>
-              <a:rPr lang="en-US" sz="1800" b="1" dirty="0">
-                <a:solidFill>
-                  <a:schemeClr val="bg1"/>
-                </a:solidFill>
-              </a:rPr>
-              <a:t>2</a:t>
-            </a:r>
-            <a:endParaRPr lang="en-US" sz="1800" dirty="0"/>
-          </a:p>
-        </p:txBody>
-      </p:sp>
-      <p:sp>
-        <p:nvSpPr>
-          <p:cNvPr id="11" name="Text 8"/>
-          <p:cNvSpPr txBox="1"/>
-          <p:nvPr/>
-        </p:nvSpPr>
-        <p:spPr>
-          <a:xfrm>
-            <a:off x="2148840" y="2148840"/>
-            <a:ext cx="1554480" cy="411480"/>
-          </a:xfrm>
-          <a:prstGeom prst="rect">
-            <a:avLst/>
-          </a:prstGeom>
-          <a:noFill/>
-          <a:ln/>
-        </p:spPr>
-        <p:txBody>
           <a:bodyPr wrap="square" lIns="0" tIns="0" rIns="0" bIns="0" rtlCol="0" anchor="t"/>
           <a:lstStyle/>
           <a:p>
-            <a:pPr algn="ctr" indent="0" marL="0">
-              <a:buNone/>
-            </a:pPr>
-            <a:r>
-              <a:rPr lang="en-US" sz="1500" b="1" dirty="0">
-                <a:solidFill>
-                  <a:schemeClr val="tx2"/>
+            <a:pPr marL="342900" indent="-342900">
+              <a:spcAft>
+                <a:spcPts val="800"/>
+              </a:spcAft>
+              <a:buSzPct val="100000"/>
+              <a:buChar char="•"/>
+            </a:pPr>
+            <a:r>
+              <a:rPr lang="en-US" sz="1500" dirty="0">
+                <a:solidFill>
+                  <a:schemeClr val="tx1"/>
                 </a:solidFill>
               </a:rPr>
-              <a:t>Component</a:t>
+              <a:t>IntelliJ: Run</a:t>
             </a:r>
             <a:endParaRPr lang="en-US" sz="1500" dirty="0"/>
           </a:p>
-        </p:txBody>
-      </p:sp>
-      <p:sp>
-        <p:nvSpPr>
-          <p:cNvPr id="12" name="Text 9"/>
-          <p:cNvSpPr txBox="1"/>
-          <p:nvPr/>
-        </p:nvSpPr>
-        <p:spPr>
-          <a:xfrm>
-            <a:off x="2176272" y="2560320"/>
-            <a:ext cx="1499616" cy="1737360"/>
-          </a:xfrm>
-          <a:prstGeom prst="rect">
-            <a:avLst/>
-          </a:prstGeom>
-          <a:noFill/>
-          <a:ln/>
-        </p:spPr>
-        <p:txBody>
-          <a:bodyPr wrap="square" lIns="0" tIns="0" rIns="0" bIns="0" rtlCol="0" anchor="t"/>
-          <a:lstStyle/>
-          <a:p>
-            <a:pPr algn="ctr" indent="0" marL="0">
-              <a:buNone/>
-            </a:pPr>
-            <a:r>
-              <a:rPr lang="en-US" sz="1300" dirty="0">
+          <a:p>
+            <a:pPr marL="342900" indent="-342900">
+              <a:spcAft>
+                <a:spcPts val="800"/>
+              </a:spcAft>
+              <a:buSzPct val="100000"/>
+              <a:buChar char="•"/>
+            </a:pPr>
+            <a:r>
+              <a:rPr lang="en-US" sz="1500" dirty="0">
                 <a:solidFill>
                   <a:schemeClr val="tx1"/>
                 </a:solidFill>
               </a:rPr>
-              <a:t>Mehrere Klassen, DB gemockt</a:t>
-            </a:r>
-            <a:endParaRPr lang="en-US" sz="1300" dirty="0"/>
-          </a:p>
-        </p:txBody>
-      </p:sp>
-      <p:sp>
-        <p:nvSpPr>
-          <p:cNvPr id="13" name="Schritt Integration"/>
-          <p:cNvSpPr/>
-          <p:nvPr/>
-        </p:nvSpPr>
-        <p:spPr>
-          <a:xfrm>
-            <a:off x="4251960" y="1371600"/>
-            <a:ext cx="640080" cy="640080"/>
-          </a:xfrm>
-          <a:prstGeom prst="ellipse">
-            <a:avLst/>
-          </a:prstGeom>
-          <a:solidFill>
-            <a:schemeClr val="accent3"/>
-          </a:solidFill>
-          <a:ln w="38100">
-            <a:solidFill>
-              <a:schemeClr val="bg1"/>
-            </a:solidFill>
-            <a:prstDash val="solid"/>
-          </a:ln>
-        </p:spPr>
-      </p:sp>
-      <p:sp>
-        <p:nvSpPr>
-          <p:cNvPr id="14" name="Text 11"/>
-          <p:cNvSpPr txBox="1"/>
-          <p:nvPr/>
-        </p:nvSpPr>
-        <p:spPr>
-          <a:xfrm>
-            <a:off x="4251960" y="1371600"/>
-            <a:ext cx="640080" cy="640080"/>
-          </a:xfrm>
-          <a:prstGeom prst="rect">
-            <a:avLst/>
-          </a:prstGeom>
-          <a:noFill/>
-          <a:ln/>
-        </p:spPr>
-        <p:txBody>
-          <a:bodyPr wrap="square" lIns="0" tIns="0" rIns="0" bIns="0" rtlCol="0" anchor="ctr"/>
-          <a:lstStyle/>
-          <a:p>
-            <a:pPr algn="ctr" indent="0" marL="0">
-              <a:buNone/>
-            </a:pPr>
-            <a:r>
-              <a:rPr lang="en-US" sz="1800" b="1" dirty="0">
-                <a:solidFill>
-                  <a:schemeClr val="bg1"/>
-                </a:solidFill>
-              </a:rPr>
-              <a:t>3</a:t>
-            </a:r>
-            <a:endParaRPr lang="en-US" sz="1800" dirty="0"/>
-          </a:p>
-        </p:txBody>
-      </p:sp>
-      <p:sp>
-        <p:nvSpPr>
-          <p:cNvPr id="15" name="Text 12"/>
-          <p:cNvSpPr txBox="1"/>
-          <p:nvPr/>
-        </p:nvSpPr>
-        <p:spPr>
-          <a:xfrm>
-            <a:off x="3794760" y="2148840"/>
-            <a:ext cx="1554480" cy="411480"/>
-          </a:xfrm>
-          <a:prstGeom prst="rect">
-            <a:avLst/>
-          </a:prstGeom>
-          <a:noFill/>
-          <a:ln/>
-        </p:spPr>
-        <p:txBody>
-          <a:bodyPr wrap="square" lIns="0" tIns="0" rIns="0" bIns="0" rtlCol="0" anchor="t"/>
-          <a:lstStyle/>
-          <a:p>
-            <a:pPr algn="ctr" indent="0" marL="0">
-              <a:buNone/>
-            </a:pPr>
-            <a:r>
-              <a:rPr lang="en-US" sz="1500" b="1" dirty="0">
-                <a:solidFill>
-                  <a:schemeClr val="tx2"/>
-                </a:solidFill>
-              </a:rPr>
-              <a:t>Integration</a:t>
+              <a:t>Konsole: mvn test</a:t>
             </a:r>
             <a:endParaRPr lang="en-US" sz="1500" dirty="0"/>
-          </a:p>
-        </p:txBody>
-      </p:sp>
-      <p:sp>
-        <p:nvSpPr>
-          <p:cNvPr id="16" name="Text 13"/>
-          <p:cNvSpPr txBox="1"/>
-          <p:nvPr/>
-        </p:nvSpPr>
-        <p:spPr>
-          <a:xfrm>
-            <a:off x="3822192" y="2560320"/>
-            <a:ext cx="1499616" cy="1737360"/>
-          </a:xfrm>
-          <a:prstGeom prst="rect">
-            <a:avLst/>
-          </a:prstGeom>
-          <a:noFill/>
-          <a:ln/>
-        </p:spPr>
-        <p:txBody>
-          <a:bodyPr wrap="square" lIns="0" tIns="0" rIns="0" bIns="0" rtlCol="0" anchor="t"/>
-          <a:lstStyle/>
-          <a:p>
-            <a:pPr algn="ctr" indent="0" marL="0">
-              <a:buNone/>
-            </a:pPr>
-            <a:r>
-              <a:rPr lang="en-US" sz="1300" dirty="0">
-                <a:solidFill>
-                  <a:schemeClr val="tx1"/>
-                </a:solidFill>
-              </a:rPr>
-              <a:t>Echte DB und APIs, QA-Team</a:t>
-            </a:r>
-            <a:endParaRPr lang="en-US" sz="1300" dirty="0"/>
-          </a:p>
-        </p:txBody>
-      </p:sp>
-      <p:sp>
-        <p:nvSpPr>
-          <p:cNvPr id="17" name="Schritt System"/>
-          <p:cNvSpPr/>
-          <p:nvPr/>
-        </p:nvSpPr>
-        <p:spPr>
-          <a:xfrm>
-            <a:off x="5897880" y="1371600"/>
-            <a:ext cx="640080" cy="640080"/>
-          </a:xfrm>
-          <a:prstGeom prst="ellipse">
-            <a:avLst/>
-          </a:prstGeom>
-          <a:solidFill>
-            <a:schemeClr val="accent3"/>
-          </a:solidFill>
-          <a:ln w="38100">
-            <a:solidFill>
-              <a:schemeClr val="bg1"/>
-            </a:solidFill>
-            <a:prstDash val="solid"/>
-          </a:ln>
-        </p:spPr>
-      </p:sp>
-      <p:sp>
-        <p:nvSpPr>
-          <p:cNvPr id="18" name="Text 15"/>
-          <p:cNvSpPr txBox="1"/>
-          <p:nvPr/>
-        </p:nvSpPr>
-        <p:spPr>
-          <a:xfrm>
-            <a:off x="5897880" y="1371600"/>
-            <a:ext cx="640080" cy="640080"/>
-          </a:xfrm>
-          <a:prstGeom prst="rect">
-            <a:avLst/>
-          </a:prstGeom>
-          <a:noFill/>
-          <a:ln/>
-        </p:spPr>
-        <p:txBody>
-          <a:bodyPr wrap="square" lIns="0" tIns="0" rIns="0" bIns="0" rtlCol="0" anchor="ctr"/>
-          <a:lstStyle/>
-          <a:p>
-            <a:pPr algn="ctr" indent="0" marL="0">
-              <a:buNone/>
-            </a:pPr>
-            <a:r>
-              <a:rPr lang="en-US" sz="1800" b="1" dirty="0">
-                <a:solidFill>
-                  <a:schemeClr val="bg1"/>
-                </a:solidFill>
-              </a:rPr>
-              <a:t>4</a:t>
-            </a:r>
-            <a:endParaRPr lang="en-US" sz="1800" dirty="0"/>
-          </a:p>
-        </p:txBody>
-      </p:sp>
-      <p:sp>
-        <p:nvSpPr>
-          <p:cNvPr id="19" name="Text 16"/>
-          <p:cNvSpPr txBox="1"/>
-          <p:nvPr/>
-        </p:nvSpPr>
-        <p:spPr>
-          <a:xfrm>
-            <a:off x="5440680" y="2148840"/>
-            <a:ext cx="1554480" cy="411480"/>
-          </a:xfrm>
-          <a:prstGeom prst="rect">
-            <a:avLst/>
-          </a:prstGeom>
-          <a:noFill/>
-          <a:ln/>
-        </p:spPr>
-        <p:txBody>
-          <a:bodyPr wrap="square" lIns="0" tIns="0" rIns="0" bIns="0" rtlCol="0" anchor="t"/>
-          <a:lstStyle/>
-          <a:p>
-            <a:pPr algn="ctr" indent="0" marL="0">
-              <a:buNone/>
-            </a:pPr>
-            <a:r>
-              <a:rPr lang="en-US" sz="1500" b="1" dirty="0">
-                <a:solidFill>
-                  <a:schemeClr val="tx2"/>
-                </a:solidFill>
-              </a:rPr>
-              <a:t>System</a:t>
-            </a:r>
-            <a:endParaRPr lang="en-US" sz="1500" dirty="0"/>
-          </a:p>
-        </p:txBody>
-      </p:sp>
-      <p:sp>
-        <p:nvSpPr>
-          <p:cNvPr id="20" name="Text 17"/>
-          <p:cNvSpPr txBox="1"/>
-          <p:nvPr/>
-        </p:nvSpPr>
-        <p:spPr>
-          <a:xfrm>
-            <a:off x="5468112" y="2560320"/>
-            <a:ext cx="1499616" cy="1737360"/>
-          </a:xfrm>
-          <a:prstGeom prst="rect">
-            <a:avLst/>
-          </a:prstGeom>
-          <a:noFill/>
-          <a:ln/>
-        </p:spPr>
-        <p:txBody>
-          <a:bodyPr wrap="square" lIns="0" tIns="0" rIns="0" bIns="0" rtlCol="0" anchor="t"/>
-          <a:lstStyle/>
-          <a:p>
-            <a:pPr algn="ctr" indent="0" marL="0">
-              <a:buNone/>
-            </a:pPr>
-            <a:r>
-              <a:rPr lang="en-US" sz="1300" dirty="0">
-                <a:solidFill>
-                  <a:schemeClr val="tx1"/>
-                </a:solidFill>
-              </a:rPr>
-              <a:t>Ganze App, auch Performance</a:t>
-            </a:r>
-            <a:endParaRPr lang="en-US" sz="1300" dirty="0"/>
-          </a:p>
-        </p:txBody>
-      </p:sp>
-      <p:sp>
-        <p:nvSpPr>
-          <p:cNvPr id="21" name="Schritt Acceptance"/>
-          <p:cNvSpPr/>
-          <p:nvPr/>
-        </p:nvSpPr>
-        <p:spPr>
-          <a:xfrm>
-            <a:off x="7543800" y="1371600"/>
-            <a:ext cx="640080" cy="640080"/>
-          </a:xfrm>
-          <a:prstGeom prst="ellipse">
-            <a:avLst/>
-          </a:prstGeom>
-          <a:solidFill>
-            <a:schemeClr val="accent1"/>
-          </a:solidFill>
-          <a:ln w="38100">
-            <a:solidFill>
-              <a:schemeClr val="bg1"/>
-            </a:solidFill>
-            <a:prstDash val="solid"/>
-          </a:ln>
-        </p:spPr>
-      </p:sp>
-      <p:sp>
-        <p:nvSpPr>
-          <p:cNvPr id="22" name="Text 19"/>
-          <p:cNvSpPr txBox="1"/>
-          <p:nvPr/>
-        </p:nvSpPr>
-        <p:spPr>
-          <a:xfrm>
-            <a:off x="7543800" y="1371600"/>
-            <a:ext cx="640080" cy="640080"/>
-          </a:xfrm>
-          <a:prstGeom prst="rect">
-            <a:avLst/>
-          </a:prstGeom>
-          <a:noFill/>
-          <a:ln/>
-        </p:spPr>
-        <p:txBody>
-          <a:bodyPr wrap="square" lIns="0" tIns="0" rIns="0" bIns="0" rtlCol="0" anchor="ctr"/>
-          <a:lstStyle/>
-          <a:p>
-            <a:pPr algn="ctr" indent="0" marL="0">
-              <a:buNone/>
-            </a:pPr>
-            <a:r>
-              <a:rPr lang="en-US" sz="1800" b="1" dirty="0">
-                <a:solidFill>
-                  <a:schemeClr val="bg1"/>
-                </a:solidFill>
-              </a:rPr>
-              <a:t>5</a:t>
-            </a:r>
-            <a:endParaRPr lang="en-US" sz="1800" dirty="0"/>
-          </a:p>
-        </p:txBody>
-      </p:sp>
-      <p:sp>
-        <p:nvSpPr>
-          <p:cNvPr id="23" name="Text 20"/>
-          <p:cNvSpPr txBox="1"/>
-          <p:nvPr/>
-        </p:nvSpPr>
-        <p:spPr>
-          <a:xfrm>
-            <a:off x="7086600" y="2148840"/>
-            <a:ext cx="1554480" cy="411480"/>
-          </a:xfrm>
-          <a:prstGeom prst="rect">
-            <a:avLst/>
-          </a:prstGeom>
-          <a:noFill/>
-          <a:ln/>
-        </p:spPr>
-        <p:txBody>
-          <a:bodyPr wrap="square" lIns="0" tIns="0" rIns="0" bIns="0" rtlCol="0" anchor="t"/>
-          <a:lstStyle/>
-          <a:p>
-            <a:pPr algn="ctr" indent="0" marL="0">
-              <a:buNone/>
-            </a:pPr>
-            <a:r>
-              <a:rPr lang="en-US" sz="1500" b="1" dirty="0">
-                <a:solidFill>
-                  <a:schemeClr val="tx2"/>
-                </a:solidFill>
-              </a:rPr>
-              <a:t>Acceptance</a:t>
-            </a:r>
-            <a:endParaRPr lang="en-US" sz="1500" dirty="0"/>
-          </a:p>
-        </p:txBody>
-      </p:sp>
-      <p:sp>
-        <p:nvSpPr>
-          <p:cNvPr id="24" name="Text 21"/>
-          <p:cNvSpPr txBox="1"/>
-          <p:nvPr/>
-        </p:nvSpPr>
-        <p:spPr>
-          <a:xfrm>
-            <a:off x="7114032" y="2560320"/>
-            <a:ext cx="1499616" cy="1737360"/>
-          </a:xfrm>
-          <a:prstGeom prst="rect">
-            <a:avLst/>
-          </a:prstGeom>
-          <a:noFill/>
-          <a:ln/>
-        </p:spPr>
-        <p:txBody>
-          <a:bodyPr wrap="square" lIns="0" tIns="0" rIns="0" bIns="0" rtlCol="0" anchor="t"/>
-          <a:lstStyle/>
-          <a:p>
-            <a:pPr algn="ctr" indent="0" marL="0">
-              <a:buNone/>
-            </a:pPr>
-            <a:r>
-              <a:rPr lang="en-US" sz="1300" dirty="0">
-                <a:solidFill>
-                  <a:schemeClr val="tx1"/>
-                </a:solidFill>
-              </a:rPr>
-              <a:t>Kunde prüft, Black-Box</a:t>
-            </a:r>
-            <a:endParaRPr lang="en-US" sz="1300" dirty="0"/>
-          </a:p>
-        </p:txBody>
-      </p:sp>
-      <p:sp>
-        <p:nvSpPr>
-          <p:cNvPr id="25" name="Text 22"/>
-          <p:cNvSpPr txBox="1"/>
-          <p:nvPr/>
-        </p:nvSpPr>
-        <p:spPr>
-          <a:xfrm>
-            <a:off x="457200" y="4023360"/>
-            <a:ext cx="8229600" cy="457200"/>
-          </a:xfrm>
-          <a:prstGeom prst="rect">
-            <a:avLst/>
-          </a:prstGeom>
-          <a:noFill/>
-          <a:ln/>
-        </p:spPr>
-        <p:txBody>
-          <a:bodyPr wrap="square" lIns="0" tIns="0" rIns="0" bIns="0" rtlCol="0" anchor="ctr"/>
-          <a:lstStyle/>
-          <a:p>
-            <a:pPr indent="0" marL="0">
-              <a:buNone/>
-            </a:pPr>
-            <a:r>
-              <a:rPr lang="en-US" sz="1400" i="1" dirty="0">
-                <a:solidFill>
-                  <a:schemeClr val="accent5"/>
-                </a:solidFill>
-              </a:rPr>
-              <a:t>Approach = wie (White/Black-Box)  ·  Level = wo  ·  Type = was (Last, Security, Regression)</a:t>
-            </a:r>
-            <a:endParaRPr lang="en-US" sz="1400" dirty="0"/>
           </a:p>
         </p:txBody>
       </p:sp>
@@ -2897,521 +2483,6 @@
                 <a:ea typeface="Cambria" pitchFamily="34" charset="-122"/>
                 <a:cs typeface="Cambria" pitchFamily="34" charset="-120"/>
               </a:rPr>
-              <a:t>Aufgabe 1: Calculator mit JUnit 5</a:t>
-            </a:r>
-            <a:endParaRPr lang="en-US" sz="2800" dirty="0"/>
-          </a:p>
-        </p:txBody>
-      </p:sp>
-      <p:sp>
-        <p:nvSpPr>
-          <p:cNvPr id="4" name="Code Box"/>
-          <p:cNvSpPr/>
-          <p:nvPr/>
-        </p:nvSpPr>
-        <p:spPr>
-          <a:xfrm>
-            <a:off x="457200" y="1097280"/>
-            <a:ext cx="5120640" cy="3383280"/>
-          </a:xfrm>
-          <a:prstGeom prst="roundRect">
-            <a:avLst>
-              <a:gd name="adj" fmla="val 2162"/>
-            </a:avLst>
-          </a:prstGeom>
-          <a:solidFill>
-            <a:schemeClr val="tx1"/>
-          </a:solidFill>
-          <a:ln w="12700">
-            <a:solidFill>
-              <a:schemeClr val="tx1"/>
-            </a:solidFill>
-            <a:prstDash val="solid"/>
-          </a:ln>
-        </p:spPr>
-      </p:sp>
-      <p:sp>
-        <p:nvSpPr>
-          <p:cNvPr id="5" name="Text 2"/>
-          <p:cNvSpPr txBox="1"/>
-          <p:nvPr/>
-        </p:nvSpPr>
-        <p:spPr>
-          <a:xfrm>
-            <a:off x="640080" y="1207008"/>
-            <a:ext cx="4754880" cy="274320"/>
-          </a:xfrm>
-          <a:prstGeom prst="rect">
-            <a:avLst/>
-          </a:prstGeom>
-          <a:noFill/>
-          <a:ln/>
-        </p:spPr>
-        <p:txBody>
-          <a:bodyPr wrap="square" lIns="0" tIns="0" rIns="0" bIns="0" rtlCol="0" anchor="ctr"/>
-          <a:lstStyle/>
-          <a:p>
-            <a:pPr indent="0" marL="0">
-              <a:buNone/>
-            </a:pPr>
-            <a:r>
-              <a:rPr lang="en-US" sz="1100" b="1" dirty="0">
-                <a:solidFill>
-                  <a:schemeClr val="accent6"/>
-                </a:solidFill>
-              </a:rPr>
-              <a:t>CalculatorTest.java</a:t>
-            </a:r>
-            <a:endParaRPr lang="en-US" sz="1100" dirty="0"/>
-          </a:p>
-        </p:txBody>
-      </p:sp>
-      <p:sp>
-        <p:nvSpPr>
-          <p:cNvPr id="6" name="Code"/>
-          <p:cNvSpPr txBox="1"/>
-          <p:nvPr/>
-        </p:nvSpPr>
-        <p:spPr>
-          <a:xfrm>
-            <a:off x="640080" y="1508760"/>
-            <a:ext cx="4754880" cy="2834640"/>
-          </a:xfrm>
-          <a:prstGeom prst="rect">
-            <a:avLst/>
-          </a:prstGeom>
-          <a:noFill/>
-          <a:ln/>
-        </p:spPr>
-        <p:txBody>
-          <a:bodyPr wrap="square" lIns="0" tIns="0" rIns="0" bIns="0" rtlCol="0" anchor="t"/>
-          <a:lstStyle/>
-          <a:p>
-            <a:pPr indent="0" marL="0">
-              <a:buNone/>
-            </a:pPr>
-            <a:r>
-              <a:rPr lang="en-US" sz="1200" dirty="0">
-                <a:solidFill>
-                  <a:schemeClr val="bg1"/>
-                </a:solidFill>
-                <a:latin typeface="Courier New" pitchFamily="34" charset="0"/>
-                <a:ea typeface="Courier New" pitchFamily="34" charset="-122"/>
-                <a:cs typeface="Courier New" pitchFamily="34" charset="-120"/>
-              </a:rPr>
-              <a:t>@BeforeEach</a:t>
-            </a:r>
-            <a:endParaRPr lang="en-US" sz="1200" dirty="0"/>
-          </a:p>
-          <a:p>
-            <a:pPr indent="0" marL="0">
-              <a:buNone/>
-            </a:pPr>
-            <a:r>
-              <a:rPr lang="en-US" sz="1200" dirty="0">
-                <a:solidFill>
-                  <a:schemeClr val="bg1"/>
-                </a:solidFill>
-                <a:latin typeface="Courier New" pitchFamily="34" charset="0"/>
-                <a:ea typeface="Courier New" pitchFamily="34" charset="-122"/>
-                <a:cs typeface="Courier New" pitchFamily="34" charset="-120"/>
-              </a:rPr>
-              <a:t>void setUp() {</a:t>
-            </a:r>
-            <a:endParaRPr lang="en-US" sz="1200" dirty="0"/>
-          </a:p>
-          <a:p>
-            <a:pPr indent="0" marL="0">
-              <a:buNone/>
-            </a:pPr>
-            <a:r>
-              <a:rPr lang="en-US" sz="1200" dirty="0">
-                <a:solidFill>
-                  <a:schemeClr val="bg1"/>
-                </a:solidFill>
-                <a:latin typeface="Courier New" pitchFamily="34" charset="0"/>
-                <a:ea typeface="Courier New" pitchFamily="34" charset="-122"/>
-                <a:cs typeface="Courier New" pitchFamily="34" charset="-120"/>
-              </a:rPr>
-              <a:t>    calculator = new Calculator();</a:t>
-            </a:r>
-            <a:endParaRPr lang="en-US" sz="1200" dirty="0"/>
-          </a:p>
-          <a:p>
-            <a:pPr indent="0" marL="0">
-              <a:buNone/>
-            </a:pPr>
-            <a:r>
-              <a:rPr lang="en-US" sz="1200" dirty="0">
-                <a:solidFill>
-                  <a:schemeClr val="bg1"/>
-                </a:solidFill>
-                <a:latin typeface="Courier New" pitchFamily="34" charset="0"/>
-                <a:ea typeface="Courier New" pitchFamily="34" charset="-122"/>
-                <a:cs typeface="Courier New" pitchFamily="34" charset="-120"/>
-              </a:rPr>
-              <a:t>}</a:t>
-            </a:r>
-            <a:endParaRPr lang="en-US" sz="1200" dirty="0"/>
-          </a:p>
-          <a:p>
-            <a:pPr indent="0" marL="0">
-              <a:buNone/>
-            </a:pPr>
-            <a:endParaRPr lang="en-US" sz="1200" dirty="0"/>
-          </a:p>
-          <a:p>
-            <a:pPr indent="0" marL="0">
-              <a:buNone/>
-            </a:pPr>
-            <a:r>
-              <a:rPr lang="en-US" sz="1200" dirty="0">
-                <a:solidFill>
-                  <a:schemeClr val="bg1"/>
-                </a:solidFill>
-                <a:latin typeface="Courier New" pitchFamily="34" charset="0"/>
-                <a:ea typeface="Courier New" pitchFamily="34" charset="-122"/>
-                <a:cs typeface="Courier New" pitchFamily="34" charset="-120"/>
-              </a:rPr>
-              <a:t>@Test</a:t>
-            </a:r>
-            <a:endParaRPr lang="en-US" sz="1200" dirty="0"/>
-          </a:p>
-          <a:p>
-            <a:pPr indent="0" marL="0">
-              <a:buNone/>
-            </a:pPr>
-            <a:r>
-              <a:rPr lang="en-US" sz="1200" dirty="0">
-                <a:solidFill>
-                  <a:schemeClr val="bg1"/>
-                </a:solidFill>
-                <a:latin typeface="Courier New" pitchFamily="34" charset="0"/>
-                <a:ea typeface="Courier New" pitchFamily="34" charset="-122"/>
-                <a:cs typeface="Courier New" pitchFamily="34" charset="-120"/>
-              </a:rPr>
-              <a:t>void divideByZeroThrowsException() {</a:t>
-            </a:r>
-            <a:endParaRPr lang="en-US" sz="1200" dirty="0"/>
-          </a:p>
-          <a:p>
-            <a:pPr indent="0" marL="0">
-              <a:buNone/>
-            </a:pPr>
-            <a:r>
-              <a:rPr lang="en-US" sz="1200" dirty="0">
-                <a:solidFill>
-                  <a:schemeClr val="bg1"/>
-                </a:solidFill>
-                <a:latin typeface="Courier New" pitchFamily="34" charset="0"/>
-                <a:ea typeface="Courier New" pitchFamily="34" charset="-122"/>
-                <a:cs typeface="Courier New" pitchFamily="34" charset="-120"/>
-              </a:rPr>
-              <a:t>    assertThrows(ArithmeticException.class,</a:t>
-            </a:r>
-            <a:endParaRPr lang="en-US" sz="1200" dirty="0"/>
-          </a:p>
-          <a:p>
-            <a:pPr indent="0" marL="0">
-              <a:buNone/>
-            </a:pPr>
-            <a:r>
-              <a:rPr lang="en-US" sz="1200" dirty="0">
-                <a:solidFill>
-                  <a:schemeClr val="bg1"/>
-                </a:solidFill>
-                <a:latin typeface="Courier New" pitchFamily="34" charset="0"/>
-                <a:ea typeface="Courier New" pitchFamily="34" charset="-122"/>
-                <a:cs typeface="Courier New" pitchFamily="34" charset="-120"/>
-              </a:rPr>
-              <a:t>        () -&gt; calculator.divide(5, 0));</a:t>
-            </a:r>
-            <a:endParaRPr lang="en-US" sz="1200" dirty="0"/>
-          </a:p>
-          <a:p>
-            <a:pPr indent="0" marL="0">
-              <a:buNone/>
-            </a:pPr>
-            <a:r>
-              <a:rPr lang="en-US" sz="1200" dirty="0">
-                <a:solidFill>
-                  <a:schemeClr val="bg1"/>
-                </a:solidFill>
-                <a:latin typeface="Courier New" pitchFamily="34" charset="0"/>
-                <a:ea typeface="Courier New" pitchFamily="34" charset="-122"/>
-                <a:cs typeface="Courier New" pitchFamily="34" charset="-120"/>
-              </a:rPr>
-              <a:t>}</a:t>
-            </a:r>
-            <a:endParaRPr lang="en-US" sz="1200" dirty="0"/>
-          </a:p>
-        </p:txBody>
-      </p:sp>
-      <p:sp>
-        <p:nvSpPr>
-          <p:cNvPr id="7" name="Kennzahl Tests grün"/>
-          <p:cNvSpPr/>
-          <p:nvPr/>
-        </p:nvSpPr>
-        <p:spPr>
-          <a:xfrm>
-            <a:off x="5852160" y="1097280"/>
-            <a:ext cx="2834640" cy="1554480"/>
-          </a:xfrm>
-          <a:prstGeom prst="roundRect">
-            <a:avLst>
-              <a:gd name="adj" fmla="val 4706"/>
-            </a:avLst>
-          </a:prstGeom>
-          <a:solidFill>
-            <a:schemeClr val="bg2"/>
-          </a:solidFill>
-          <a:ln w="12700">
-            <a:solidFill>
-              <a:schemeClr val="bg2"/>
-            </a:solidFill>
-            <a:prstDash val="solid"/>
-          </a:ln>
-        </p:spPr>
-      </p:sp>
-      <p:sp>
-        <p:nvSpPr>
-          <p:cNvPr id="8" name="Text 5"/>
-          <p:cNvSpPr txBox="1"/>
-          <p:nvPr/>
-        </p:nvSpPr>
-        <p:spPr>
-          <a:xfrm>
-            <a:off x="5852160" y="1280160"/>
-            <a:ext cx="2834640" cy="777240"/>
-          </a:xfrm>
-          <a:prstGeom prst="rect">
-            <a:avLst/>
-          </a:prstGeom>
-          <a:noFill/>
-          <a:ln/>
-        </p:spPr>
-        <p:txBody>
-          <a:bodyPr wrap="square" lIns="0" tIns="0" rIns="0" bIns="0" rtlCol="0" anchor="ctr"/>
-          <a:lstStyle/>
-          <a:p>
-            <a:pPr algn="ctr" indent="0" marL="0">
-              <a:buNone/>
-            </a:pPr>
-            <a:r>
-              <a:rPr lang="en-US" sz="3600" b="1" dirty="0">
-                <a:solidFill>
-                  <a:schemeClr val="accent1"/>
-                </a:solidFill>
-                <a:latin typeface="Cambria" pitchFamily="34" charset="0"/>
-                <a:ea typeface="Cambria" pitchFamily="34" charset="-122"/>
-                <a:cs typeface="Cambria" pitchFamily="34" charset="-120"/>
-              </a:rPr>
-              <a:t>14</a:t>
-            </a:r>
-            <a:endParaRPr lang="en-US" sz="3600" dirty="0"/>
-          </a:p>
-        </p:txBody>
-      </p:sp>
-      <p:sp>
-        <p:nvSpPr>
-          <p:cNvPr id="9" name="Text 6"/>
-          <p:cNvSpPr txBox="1"/>
-          <p:nvPr/>
-        </p:nvSpPr>
-        <p:spPr>
-          <a:xfrm>
-            <a:off x="5943600" y="2057400"/>
-            <a:ext cx="2651760" cy="457200"/>
-          </a:xfrm>
-          <a:prstGeom prst="rect">
-            <a:avLst/>
-          </a:prstGeom>
-          <a:noFill/>
-          <a:ln/>
-        </p:spPr>
-        <p:txBody>
-          <a:bodyPr wrap="square" lIns="0" tIns="0" rIns="0" bIns="0" rtlCol="0" anchor="t"/>
-          <a:lstStyle/>
-          <a:p>
-            <a:pPr algn="ctr" indent="0" marL="0">
-              <a:buNone/>
-            </a:pPr>
-            <a:r>
-              <a:rPr lang="en-US" sz="1200" dirty="0">
-                <a:solidFill>
-                  <a:schemeClr val="tx1"/>
-                </a:solidFill>
-              </a:rPr>
-              <a:t>Tests grün</a:t>
-            </a:r>
-            <a:endParaRPr lang="en-US" sz="1200" dirty="0"/>
-          </a:p>
-        </p:txBody>
-      </p:sp>
-      <p:sp>
-        <p:nvSpPr>
-          <p:cNvPr id="10" name="Text 7"/>
-          <p:cNvSpPr txBox="1"/>
-          <p:nvPr/>
-        </p:nvSpPr>
-        <p:spPr>
-          <a:xfrm>
-            <a:off x="5943600" y="2926080"/>
-            <a:ext cx="2743200" cy="1280160"/>
-          </a:xfrm>
-          <a:prstGeom prst="rect">
-            <a:avLst/>
-          </a:prstGeom>
-          <a:noFill/>
-          <a:ln/>
-        </p:spPr>
-        <p:txBody>
-          <a:bodyPr wrap="square" lIns="0" tIns="0" rIns="0" bIns="0" rtlCol="0" anchor="t"/>
-          <a:lstStyle/>
-          <a:p>
-            <a:pPr marL="342900" indent="-342900">
-              <a:spcAft>
-                <a:spcPts val="800"/>
-              </a:spcAft>
-              <a:buSzPct val="100000"/>
-              <a:buChar char="•"/>
-            </a:pPr>
-            <a:r>
-              <a:rPr lang="en-US" sz="1500" dirty="0">
-                <a:solidFill>
-                  <a:schemeClr val="tx1"/>
-                </a:solidFill>
-              </a:rPr>
-              <a:t>IntelliJ: Run</a:t>
-            </a:r>
-            <a:endParaRPr lang="en-US" sz="1500" dirty="0"/>
-          </a:p>
-          <a:p>
-            <a:pPr marL="342900" indent="-342900">
-              <a:spcAft>
-                <a:spcPts val="800"/>
-              </a:spcAft>
-              <a:buSzPct val="100000"/>
-              <a:buChar char="•"/>
-            </a:pPr>
-            <a:r>
-              <a:rPr lang="en-US" sz="1500" dirty="0">
-                <a:solidFill>
-                  <a:schemeClr val="tx1"/>
-                </a:solidFill>
-              </a:rPr>
-              <a:t>Konsole: mvn test</a:t>
-            </a:r>
-            <a:endParaRPr lang="en-US" sz="1500" dirty="0"/>
-          </a:p>
-        </p:txBody>
-      </p:sp>
-      <p:sp>
-        <p:nvSpPr>
-          <p:cNvPr id="25" name="Slide Number Placeholder 0"/>
-          <p:cNvSpPr>
-            <a:spLocks noGrp="1"/>
-          </p:cNvSpPr>
-          <p:nvPr>
-            <p:ph type="sldNum" sz="quarter" idx="4294967295"/>
-          </p:nvPr>
-        </p:nvSpPr>
-        <p:spPr>
-          <a:xfrm>
-            <a:off x="8229600" y="4754880"/>
-            <a:ext cx="457200" cy="228600"/>
-          </a:xfrm>
-          <a:prstGeom prst="rect">
-            <a:avLst/>
-          </a:prstGeom>
-          <a:extLst>
-            <a:ext uri="{C572A759-6A51-4108-AA02-DFA0A04FC94B}">
-              <ma14:wrappingTextBoxFlag xmlns:ma14="http://schemas.microsoft.com/office/mac/drawingml/2011/main" val="0"/>
-            </a:ext>
-          </a:extLst>
-        </p:spPr>
-        <p:txBody>
-          <a:bodyPr/>
-          <a:lstStyle>
-            <a:lvl1pPr>
-              <a:defRPr sz="1000">
-                <a:solidFill>
-                  <a:schemeClr val="accent5"/>
-                </a:solidFill>
-              </a:defRPr>
-            </a:lvl1pPr>
-          </a:lstStyle>
-          <a:p>
-            <a:pPr algn="r"/>
-            <a:fld id="{F7021451-1387-4CA6-816F-3879F97B5CBC}" type="slidenum">
-              <a:rPr b="0" lang="en-US"/>
-              <a:t>3</a:t>
-            </a:fld>
-            <a:endParaRPr lang="en-US"/>
-          </a:p>
-        </p:txBody>
-      </p:sp>
-    </p:spTree>
-  </p:cSld>
-  <p:clrMapOvr>
-    <a:masterClrMapping/>
-  </p:clrMapOvr>
-</p:sld>
-</file>
-
-<file path=ppt/slides/slide4.xml><?xml version="1.0" encoding="utf-8"?>
-<p:sld xmlns:a="http://schemas.openxmlformats.org/drawingml/2006/main" xmlns:r="http://schemas.openxmlformats.org/officeDocument/2006/relationships" xmlns:p="http://schemas.openxmlformats.org/presentationml/2006/main">
-  <p:cSld name="Slide 4">
-    <p:spTree>
-      <p:nvGrpSpPr>
-        <p:cNvPr id="1" name=""/>
-        <p:cNvGrpSpPr/>
-        <p:nvPr/>
-      </p:nvGrpSpPr>
-      <p:grpSpPr>
-        <a:xfrm>
-          <a:off x="0" y="0"/>
-          <a:ext cx="0" cy="0"/>
-          <a:chOff x="0" y="0"/>
-          <a:chExt cx="0" cy="0"/>
-        </a:xfrm>
-      </p:grpSpPr>
-      <p:sp>
-        <p:nvSpPr>
-          <p:cNvPr id="2" name="Text 0"/>
-          <p:cNvSpPr/>
-          <p:nvPr>
-            <p:ph idx="100" type="title" hasCustomPrompt="1"/>
-          </p:nvPr>
-        </p:nvSpPr>
-        <p:spPr>
-          <a:xfrm>
-            <a:off x="457200" y="274320"/>
-            <a:ext cx="8229600" cy="594360"/>
-          </a:xfrm>
-          <a:prstGeom prst="rect">
-            <a:avLst/>
-          </a:prstGeom>
-          <a:noFill/>
-          <a:ln/>
-        </p:spPr>
-        <p:txBody>
-          <a:bodyPr wrap="square" lIns="0" tIns="0" rIns="0" bIns="0" rtlCol="0" anchor="ctr"/>
-          <a:lstStyle/>
-          <a:p>
-            <a:pPr algn="l" indent="0" marL="0">
-              <a:buNone/>
-            </a:pPr>
-            <a:r>
-              <a:rPr lang="en-US" sz="2800" b="1" dirty="0">
-                <a:solidFill>
-                  <a:schemeClr val="tx2"/>
-                </a:solidFill>
-                <a:latin typeface="Cambria" pitchFamily="34" charset="0"/>
-                <a:ea typeface="Cambria" pitchFamily="34" charset="-122"/>
-                <a:cs typeface="Cambria" pitchFamily="34" charset="-120"/>
-              </a:rPr>
               <a:t>Aufgabe 2: Die wichtigsten JUnit Features</a:t>
             </a:r>
             <a:endParaRPr lang="en-US" sz="2800" dirty="0"/>
@@ -3420,7 +2491,7 @@
       </p:sp>
       <p:graphicFrame>
         <p:nvGraphicFramePr>
-          <p:cNvPr id="5" name="Tabelle"/>
+          <p:cNvPr id="4" name="Tabelle"/>
           <p:cNvGraphicFramePr>
             <a:graphicFrameLocks noGrp="1"/>
           </p:cNvGraphicFramePr>
@@ -4591,6 +3662,942 @@
             <a:pPr algn="r"/>
             <a:fld id="{F7021451-1387-4CA6-816F-3879F97B5CBC}" type="slidenum">
               <a:rPr b="0" lang="en-US"/>
+              <a:t>3</a:t>
+            </a:fld>
+            <a:endParaRPr lang="en-US"/>
+          </a:p>
+        </p:txBody>
+      </p:sp>
+    </p:spTree>
+  </p:cSld>
+  <p:clrMapOvr>
+    <a:masterClrMapping/>
+  </p:clrMapOvr>
+</p:sld>
+</file>
+
+<file path=ppt/slides/slide4.xml><?xml version="1.0" encoding="utf-8"?>
+<p:sld xmlns:a="http://schemas.openxmlformats.org/drawingml/2006/main" xmlns:r="http://schemas.openxmlformats.org/officeDocument/2006/relationships" xmlns:p="http://schemas.openxmlformats.org/presentationml/2006/main">
+  <p:cSld name="Slide 4">
+    <p:spTree>
+      <p:nvGrpSpPr>
+        <p:cNvPr id="1" name=""/>
+        <p:cNvGrpSpPr/>
+        <p:nvPr/>
+      </p:nvGrpSpPr>
+      <p:grpSpPr>
+        <a:xfrm>
+          <a:off x="0" y="0"/>
+          <a:ext cx="0" cy="0"/>
+          <a:chOff x="0" y="0"/>
+          <a:chExt cx="0" cy="0"/>
+        </a:xfrm>
+      </p:grpSpPr>
+      <p:sp>
+        <p:nvSpPr>
+          <p:cNvPr id="2" name="Text 0"/>
+          <p:cNvSpPr/>
+          <p:nvPr>
+            <p:ph idx="100" type="title" hasCustomPrompt="1"/>
+          </p:nvPr>
+        </p:nvSpPr>
+        <p:spPr>
+          <a:xfrm>
+            <a:off x="457200" y="274320"/>
+            <a:ext cx="8229600" cy="594360"/>
+          </a:xfrm>
+          <a:prstGeom prst="rect">
+            <a:avLst/>
+          </a:prstGeom>
+          <a:noFill/>
+          <a:ln/>
+        </p:spPr>
+        <p:txBody>
+          <a:bodyPr wrap="square" lIns="0" tIns="0" rIns="0" bIns="0" rtlCol="0" anchor="ctr"/>
+          <a:lstStyle/>
+          <a:p>
+            <a:pPr algn="l" indent="0" marL="0">
+              <a:buNone/>
+            </a:pPr>
+            <a:r>
+              <a:rPr lang="en-US" sz="2800" b="1" dirty="0">
+                <a:solidFill>
+                  <a:schemeClr val="tx2"/>
+                </a:solidFill>
+                <a:latin typeface="Cambria" pitchFamily="34" charset="0"/>
+                <a:ea typeface="Cambria" pitchFamily="34" charset="-122"/>
+                <a:cs typeface="Cambria" pitchFamily="34" charset="-120"/>
+              </a:rPr>
+              <a:t>Aufgabe 3: Aufbau der Bank-Simulation</a:t>
+            </a:r>
+            <a:endParaRPr lang="en-US" sz="2800" dirty="0"/>
+          </a:p>
+        </p:txBody>
+      </p:sp>
+      <p:sp>
+        <p:nvSpPr>
+          <p:cNvPr id="4" name="Karte SavingsAccount"/>
+          <p:cNvSpPr/>
+          <p:nvPr/>
+        </p:nvSpPr>
+        <p:spPr>
+          <a:xfrm>
+            <a:off x="457200" y="1097280"/>
+            <a:ext cx="2560320" cy="1828800"/>
+          </a:xfrm>
+          <a:prstGeom prst="roundRect">
+            <a:avLst>
+              <a:gd name="adj" fmla="val 4000"/>
+            </a:avLst>
+          </a:prstGeom>
+          <a:solidFill>
+            <a:schemeClr val="bg2"/>
+          </a:solidFill>
+          <a:ln w="12700">
+            <a:solidFill>
+              <a:schemeClr val="bg2"/>
+            </a:solidFill>
+            <a:prstDash val="solid"/>
+          </a:ln>
+        </p:spPr>
+      </p:sp>
+      <p:sp>
+        <p:nvSpPr>
+          <p:cNvPr id="5" name="Badge 1"/>
+          <p:cNvSpPr/>
+          <p:nvPr/>
+        </p:nvSpPr>
+        <p:spPr>
+          <a:xfrm>
+            <a:off x="640080" y="1280160"/>
+            <a:ext cx="384048" cy="384048"/>
+          </a:xfrm>
+          <a:prstGeom prst="ellipse">
+            <a:avLst/>
+          </a:prstGeom>
+          <a:solidFill>
+            <a:schemeClr val="accent3"/>
+          </a:solidFill>
+          <a:ln w="12700">
+            <a:solidFill>
+              <a:schemeClr val="accent3"/>
+            </a:solidFill>
+            <a:prstDash val="solid"/>
+          </a:ln>
+        </p:spPr>
+      </p:sp>
+      <p:sp>
+        <p:nvSpPr>
+          <p:cNvPr id="6" name="Text 3"/>
+          <p:cNvSpPr txBox="1"/>
+          <p:nvPr/>
+        </p:nvSpPr>
+        <p:spPr>
+          <a:xfrm>
+            <a:off x="640080" y="1280160"/>
+            <a:ext cx="384048" cy="384048"/>
+          </a:xfrm>
+          <a:prstGeom prst="rect">
+            <a:avLst/>
+          </a:prstGeom>
+          <a:noFill/>
+          <a:ln/>
+        </p:spPr>
+        <p:txBody>
+          <a:bodyPr wrap="square" lIns="0" tIns="0" rIns="0" bIns="0" rtlCol="0" anchor="ctr"/>
+          <a:lstStyle/>
+          <a:p>
+            <a:pPr algn="ctr" indent="0" marL="0">
+              <a:buNone/>
+            </a:pPr>
+            <a:r>
+              <a:rPr lang="en-US" sz="1400" b="1" dirty="0">
+                <a:solidFill>
+                  <a:schemeClr val="bg1"/>
+                </a:solidFill>
+              </a:rPr>
+              <a:t>1</a:t>
+            </a:r>
+            <a:endParaRPr lang="en-US" sz="1400" dirty="0"/>
+          </a:p>
+        </p:txBody>
+      </p:sp>
+      <p:sp>
+        <p:nvSpPr>
+          <p:cNvPr id="7" name="Text 4"/>
+          <p:cNvSpPr txBox="1"/>
+          <p:nvPr/>
+        </p:nvSpPr>
+        <p:spPr>
+          <a:xfrm>
+            <a:off x="1143000" y="1252728"/>
+            <a:ext cx="1737360" cy="438912"/>
+          </a:xfrm>
+          <a:prstGeom prst="rect">
+            <a:avLst/>
+          </a:prstGeom>
+          <a:noFill/>
+          <a:ln/>
+        </p:spPr>
+        <p:txBody>
+          <a:bodyPr wrap="square" lIns="0" tIns="0" rIns="0" bIns="0" rtlCol="0" anchor="ctr">
+            <a:normAutofit/>
+          </a:bodyPr>
+          <a:lstStyle/>
+          <a:p>
+            <a:pPr indent="0" marL="0">
+              <a:buNone/>
+            </a:pPr>
+            <a:r>
+              <a:rPr lang="en-US" sz="1600" b="1" dirty="0">
+                <a:solidFill>
+                  <a:schemeClr val="tx2"/>
+                </a:solidFill>
+              </a:rPr>
+              <a:t>SavingsAccount</a:t>
+            </a:r>
+            <a:endParaRPr lang="en-US" sz="1600" dirty="0"/>
+          </a:p>
+        </p:txBody>
+      </p:sp>
+      <p:sp>
+        <p:nvSpPr>
+          <p:cNvPr id="8" name="Text 5"/>
+          <p:cNvSpPr txBox="1"/>
+          <p:nvPr/>
+        </p:nvSpPr>
+        <p:spPr>
+          <a:xfrm>
+            <a:off x="640080" y="1828800"/>
+            <a:ext cx="2194560" cy="987552"/>
+          </a:xfrm>
+          <a:prstGeom prst="rect">
+            <a:avLst/>
+          </a:prstGeom>
+          <a:noFill/>
+          <a:ln/>
+        </p:spPr>
+        <p:txBody>
+          <a:bodyPr wrap="square" lIns="0" tIns="0" rIns="0" bIns="0" rtlCol="0" anchor="t"/>
+          <a:lstStyle/>
+          <a:p>
+            <a:pPr indent="0" marL="0">
+              <a:spcAft>
+                <a:spcPts val="400"/>
+              </a:spcAft>
+              <a:buNone/>
+            </a:pPr>
+            <a:r>
+              <a:rPr lang="en-US" sz="1400" dirty="0">
+                <a:solidFill>
+                  <a:schemeClr val="tx1"/>
+                </a:solidFill>
+              </a:rPr>
+              <a:t>Kontostand nie unter 0</a:t>
+            </a:r>
+            <a:endParaRPr lang="en-US" sz="1400" dirty="0"/>
+          </a:p>
+        </p:txBody>
+      </p:sp>
+      <p:sp>
+        <p:nvSpPr>
+          <p:cNvPr id="9" name="Karte PromoYouthSavings"/>
+          <p:cNvSpPr/>
+          <p:nvPr/>
+        </p:nvSpPr>
+        <p:spPr>
+          <a:xfrm>
+            <a:off x="3291840" y="1097280"/>
+            <a:ext cx="2560320" cy="1828800"/>
+          </a:xfrm>
+          <a:prstGeom prst="roundRect">
+            <a:avLst>
+              <a:gd name="adj" fmla="val 4000"/>
+            </a:avLst>
+          </a:prstGeom>
+          <a:solidFill>
+            <a:schemeClr val="bg2"/>
+          </a:solidFill>
+          <a:ln w="12700">
+            <a:solidFill>
+              <a:schemeClr val="bg2"/>
+            </a:solidFill>
+            <a:prstDash val="solid"/>
+          </a:ln>
+        </p:spPr>
+      </p:sp>
+      <p:sp>
+        <p:nvSpPr>
+          <p:cNvPr id="10" name="Badge 2"/>
+          <p:cNvSpPr/>
+          <p:nvPr/>
+        </p:nvSpPr>
+        <p:spPr>
+          <a:xfrm>
+            <a:off x="3474720" y="1280160"/>
+            <a:ext cx="384048" cy="384048"/>
+          </a:xfrm>
+          <a:prstGeom prst="ellipse">
+            <a:avLst/>
+          </a:prstGeom>
+          <a:solidFill>
+            <a:schemeClr val="accent3"/>
+          </a:solidFill>
+          <a:ln w="12700">
+            <a:solidFill>
+              <a:schemeClr val="accent3"/>
+            </a:solidFill>
+            <a:prstDash val="solid"/>
+          </a:ln>
+        </p:spPr>
+      </p:sp>
+      <p:sp>
+        <p:nvSpPr>
+          <p:cNvPr id="11" name="Text 8"/>
+          <p:cNvSpPr txBox="1"/>
+          <p:nvPr/>
+        </p:nvSpPr>
+        <p:spPr>
+          <a:xfrm>
+            <a:off x="3474720" y="1280160"/>
+            <a:ext cx="384048" cy="384048"/>
+          </a:xfrm>
+          <a:prstGeom prst="rect">
+            <a:avLst/>
+          </a:prstGeom>
+          <a:noFill/>
+          <a:ln/>
+        </p:spPr>
+        <p:txBody>
+          <a:bodyPr wrap="square" lIns="0" tIns="0" rIns="0" bIns="0" rtlCol="0" anchor="ctr"/>
+          <a:lstStyle/>
+          <a:p>
+            <a:pPr algn="ctr" indent="0" marL="0">
+              <a:buNone/>
+            </a:pPr>
+            <a:r>
+              <a:rPr lang="en-US" sz="1400" b="1" dirty="0">
+                <a:solidFill>
+                  <a:schemeClr val="bg1"/>
+                </a:solidFill>
+              </a:rPr>
+              <a:t>2</a:t>
+            </a:r>
+            <a:endParaRPr lang="en-US" sz="1400" dirty="0"/>
+          </a:p>
+        </p:txBody>
+      </p:sp>
+      <p:sp>
+        <p:nvSpPr>
+          <p:cNvPr id="12" name="Text 9"/>
+          <p:cNvSpPr txBox="1"/>
+          <p:nvPr/>
+        </p:nvSpPr>
+        <p:spPr>
+          <a:xfrm>
+            <a:off x="3977640" y="1252728"/>
+            <a:ext cx="1737360" cy="438912"/>
+          </a:xfrm>
+          <a:prstGeom prst="rect">
+            <a:avLst/>
+          </a:prstGeom>
+          <a:noFill/>
+          <a:ln/>
+        </p:spPr>
+        <p:txBody>
+          <a:bodyPr wrap="square" lIns="0" tIns="0" rIns="0" bIns="0" rtlCol="0" anchor="ctr">
+            <a:normAutofit/>
+          </a:bodyPr>
+          <a:lstStyle/>
+          <a:p>
+            <a:pPr indent="0" marL="0">
+              <a:buNone/>
+            </a:pPr>
+            <a:r>
+              <a:rPr lang="en-US" sz="1600" b="1" dirty="0">
+                <a:solidFill>
+                  <a:schemeClr val="tx2"/>
+                </a:solidFill>
+              </a:rPr>
+              <a:t>PromoYouthSavings</a:t>
+            </a:r>
+            <a:endParaRPr lang="en-US" sz="1600" dirty="0"/>
+          </a:p>
+        </p:txBody>
+      </p:sp>
+      <p:sp>
+        <p:nvSpPr>
+          <p:cNvPr id="13" name="Text 10"/>
+          <p:cNvSpPr txBox="1"/>
+          <p:nvPr/>
+        </p:nvSpPr>
+        <p:spPr>
+          <a:xfrm>
+            <a:off x="3474720" y="1828800"/>
+            <a:ext cx="2194560" cy="987552"/>
+          </a:xfrm>
+          <a:prstGeom prst="rect">
+            <a:avLst/>
+          </a:prstGeom>
+          <a:noFill/>
+          <a:ln/>
+        </p:spPr>
+        <p:txBody>
+          <a:bodyPr wrap="square" lIns="0" tIns="0" rIns="0" bIns="0" rtlCol="0" anchor="t"/>
+          <a:lstStyle/>
+          <a:p>
+            <a:pPr indent="0" marL="0">
+              <a:spcAft>
+                <a:spcPts val="400"/>
+              </a:spcAft>
+              <a:buNone/>
+            </a:pPr>
+            <a:r>
+              <a:rPr lang="en-US" sz="1400" dirty="0">
+                <a:solidFill>
+                  <a:schemeClr val="tx1"/>
+                </a:solidFill>
+              </a:rPr>
+              <a:t>+1 % Bonus bei jeder Einzahlung</a:t>
+            </a:r>
+            <a:endParaRPr lang="en-US" sz="1400" dirty="0"/>
+          </a:p>
+        </p:txBody>
+      </p:sp>
+      <p:sp>
+        <p:nvSpPr>
+          <p:cNvPr id="14" name="Karte SalaryAccount"/>
+          <p:cNvSpPr/>
+          <p:nvPr/>
+        </p:nvSpPr>
+        <p:spPr>
+          <a:xfrm>
+            <a:off x="6126480" y="1097280"/>
+            <a:ext cx="2560320" cy="1828800"/>
+          </a:xfrm>
+          <a:prstGeom prst="roundRect">
+            <a:avLst>
+              <a:gd name="adj" fmla="val 4000"/>
+            </a:avLst>
+          </a:prstGeom>
+          <a:solidFill>
+            <a:schemeClr val="bg2"/>
+          </a:solidFill>
+          <a:ln w="12700">
+            <a:solidFill>
+              <a:schemeClr val="bg2"/>
+            </a:solidFill>
+            <a:prstDash val="solid"/>
+          </a:ln>
+        </p:spPr>
+      </p:sp>
+      <p:sp>
+        <p:nvSpPr>
+          <p:cNvPr id="15" name="Badge 3"/>
+          <p:cNvSpPr/>
+          <p:nvPr/>
+        </p:nvSpPr>
+        <p:spPr>
+          <a:xfrm>
+            <a:off x="6309360" y="1280160"/>
+            <a:ext cx="384048" cy="384048"/>
+          </a:xfrm>
+          <a:prstGeom prst="ellipse">
+            <a:avLst/>
+          </a:prstGeom>
+          <a:solidFill>
+            <a:schemeClr val="accent3"/>
+          </a:solidFill>
+          <a:ln w="12700">
+            <a:solidFill>
+              <a:schemeClr val="accent3"/>
+            </a:solidFill>
+            <a:prstDash val="solid"/>
+          </a:ln>
+        </p:spPr>
+      </p:sp>
+      <p:sp>
+        <p:nvSpPr>
+          <p:cNvPr id="16" name="Text 13"/>
+          <p:cNvSpPr txBox="1"/>
+          <p:nvPr/>
+        </p:nvSpPr>
+        <p:spPr>
+          <a:xfrm>
+            <a:off x="6309360" y="1280160"/>
+            <a:ext cx="384048" cy="384048"/>
+          </a:xfrm>
+          <a:prstGeom prst="rect">
+            <a:avLst/>
+          </a:prstGeom>
+          <a:noFill/>
+          <a:ln/>
+        </p:spPr>
+        <p:txBody>
+          <a:bodyPr wrap="square" lIns="0" tIns="0" rIns="0" bIns="0" rtlCol="0" anchor="ctr"/>
+          <a:lstStyle/>
+          <a:p>
+            <a:pPr algn="ctr" indent="0" marL="0">
+              <a:buNone/>
+            </a:pPr>
+            <a:r>
+              <a:rPr lang="en-US" sz="1400" b="1" dirty="0">
+                <a:solidFill>
+                  <a:schemeClr val="bg1"/>
+                </a:solidFill>
+              </a:rPr>
+              <a:t>3</a:t>
+            </a:r>
+            <a:endParaRPr lang="en-US" sz="1400" dirty="0"/>
+          </a:p>
+        </p:txBody>
+      </p:sp>
+      <p:sp>
+        <p:nvSpPr>
+          <p:cNvPr id="17" name="Text 14"/>
+          <p:cNvSpPr txBox="1"/>
+          <p:nvPr/>
+        </p:nvSpPr>
+        <p:spPr>
+          <a:xfrm>
+            <a:off x="6812280" y="1252728"/>
+            <a:ext cx="1737360" cy="438912"/>
+          </a:xfrm>
+          <a:prstGeom prst="rect">
+            <a:avLst/>
+          </a:prstGeom>
+          <a:noFill/>
+          <a:ln/>
+        </p:spPr>
+        <p:txBody>
+          <a:bodyPr wrap="square" lIns="0" tIns="0" rIns="0" bIns="0" rtlCol="0" anchor="ctr">
+            <a:normAutofit/>
+          </a:bodyPr>
+          <a:lstStyle/>
+          <a:p>
+            <a:pPr indent="0" marL="0">
+              <a:buNone/>
+            </a:pPr>
+            <a:r>
+              <a:rPr lang="en-US" sz="1600" b="1" dirty="0">
+                <a:solidFill>
+                  <a:schemeClr val="tx2"/>
+                </a:solidFill>
+              </a:rPr>
+              <a:t>SalaryAccount</a:t>
+            </a:r>
+            <a:endParaRPr lang="en-US" sz="1600" dirty="0"/>
+          </a:p>
+        </p:txBody>
+      </p:sp>
+      <p:sp>
+        <p:nvSpPr>
+          <p:cNvPr id="18" name="Text 15"/>
+          <p:cNvSpPr txBox="1"/>
+          <p:nvPr/>
+        </p:nvSpPr>
+        <p:spPr>
+          <a:xfrm>
+            <a:off x="6309360" y="1828800"/>
+            <a:ext cx="2194560" cy="987552"/>
+          </a:xfrm>
+          <a:prstGeom prst="rect">
+            <a:avLst/>
+          </a:prstGeom>
+          <a:noFill/>
+          <a:ln/>
+        </p:spPr>
+        <p:txBody>
+          <a:bodyPr wrap="square" lIns="0" tIns="0" rIns="0" bIns="0" rtlCol="0" anchor="t"/>
+          <a:lstStyle/>
+          <a:p>
+            <a:pPr indent="0" marL="0">
+              <a:spcAft>
+                <a:spcPts val="400"/>
+              </a:spcAft>
+              <a:buNone/>
+            </a:pPr>
+            <a:r>
+              <a:rPr lang="en-US" sz="1400" dirty="0">
+                <a:solidFill>
+                  <a:schemeClr val="tx1"/>
+                </a:solidFill>
+              </a:rPr>
+              <a:t>Darf bis zur Kreditlimite ins Minus</a:t>
+            </a:r>
+            <a:endParaRPr lang="en-US" sz="1400" dirty="0"/>
+          </a:p>
+        </p:txBody>
+      </p:sp>
+      <p:sp>
+        <p:nvSpPr>
+          <p:cNvPr id="19" name="Karte Bank"/>
+          <p:cNvSpPr/>
+          <p:nvPr/>
+        </p:nvSpPr>
+        <p:spPr>
+          <a:xfrm>
+            <a:off x="457200" y="3200400"/>
+            <a:ext cx="3977640" cy="1325880"/>
+          </a:xfrm>
+          <a:prstGeom prst="roundRect">
+            <a:avLst>
+              <a:gd name="adj" fmla="val 5517"/>
+            </a:avLst>
+          </a:prstGeom>
+          <a:solidFill>
+            <a:schemeClr val="bg2"/>
+          </a:solidFill>
+          <a:ln w="12700">
+            <a:solidFill>
+              <a:schemeClr val="bg2"/>
+            </a:solidFill>
+            <a:prstDash val="solid"/>
+          </a:ln>
+        </p:spPr>
+      </p:sp>
+      <p:sp>
+        <p:nvSpPr>
+          <p:cNvPr id="20" name="Badge B"/>
+          <p:cNvSpPr/>
+          <p:nvPr/>
+        </p:nvSpPr>
+        <p:spPr>
+          <a:xfrm>
+            <a:off x="640080" y="3383280"/>
+            <a:ext cx="384048" cy="384048"/>
+          </a:xfrm>
+          <a:prstGeom prst="ellipse">
+            <a:avLst/>
+          </a:prstGeom>
+          <a:solidFill>
+            <a:schemeClr val="accent3"/>
+          </a:solidFill>
+          <a:ln w="12700">
+            <a:solidFill>
+              <a:schemeClr val="accent3"/>
+            </a:solidFill>
+            <a:prstDash val="solid"/>
+          </a:ln>
+        </p:spPr>
+      </p:sp>
+      <p:sp>
+        <p:nvSpPr>
+          <p:cNvPr id="21" name="Text 18"/>
+          <p:cNvSpPr txBox="1"/>
+          <p:nvPr/>
+        </p:nvSpPr>
+        <p:spPr>
+          <a:xfrm>
+            <a:off x="640080" y="3383280"/>
+            <a:ext cx="384048" cy="384048"/>
+          </a:xfrm>
+          <a:prstGeom prst="rect">
+            <a:avLst/>
+          </a:prstGeom>
+          <a:noFill/>
+          <a:ln/>
+        </p:spPr>
+        <p:txBody>
+          <a:bodyPr wrap="square" lIns="0" tIns="0" rIns="0" bIns="0" rtlCol="0" anchor="ctr"/>
+          <a:lstStyle/>
+          <a:p>
+            <a:pPr algn="ctr" indent="0" marL="0">
+              <a:buNone/>
+            </a:pPr>
+            <a:r>
+              <a:rPr lang="en-US" sz="1400" b="1" dirty="0">
+                <a:solidFill>
+                  <a:schemeClr val="bg1"/>
+                </a:solidFill>
+              </a:rPr>
+              <a:t>B</a:t>
+            </a:r>
+            <a:endParaRPr lang="en-US" sz="1400" dirty="0"/>
+          </a:p>
+        </p:txBody>
+      </p:sp>
+      <p:sp>
+        <p:nvSpPr>
+          <p:cNvPr id="22" name="Text 19"/>
+          <p:cNvSpPr txBox="1"/>
+          <p:nvPr/>
+        </p:nvSpPr>
+        <p:spPr>
+          <a:xfrm>
+            <a:off x="1143000" y="3355848"/>
+            <a:ext cx="3154680" cy="438912"/>
+          </a:xfrm>
+          <a:prstGeom prst="rect">
+            <a:avLst/>
+          </a:prstGeom>
+          <a:noFill/>
+          <a:ln/>
+        </p:spPr>
+        <p:txBody>
+          <a:bodyPr wrap="square" lIns="0" tIns="0" rIns="0" bIns="0" rtlCol="0" anchor="ctr">
+            <a:normAutofit/>
+          </a:bodyPr>
+          <a:lstStyle/>
+          <a:p>
+            <a:pPr indent="0" marL="0">
+              <a:buNone/>
+            </a:pPr>
+            <a:r>
+              <a:rPr lang="en-US" sz="1600" b="1" dirty="0">
+                <a:solidFill>
+                  <a:schemeClr val="tx2"/>
+                </a:solidFill>
+              </a:rPr>
+              <a:t>Bank</a:t>
+            </a:r>
+            <a:endParaRPr lang="en-US" sz="1600" dirty="0"/>
+          </a:p>
+        </p:txBody>
+      </p:sp>
+      <p:sp>
+        <p:nvSpPr>
+          <p:cNvPr id="23" name="Text 20"/>
+          <p:cNvSpPr txBox="1"/>
+          <p:nvPr/>
+        </p:nvSpPr>
+        <p:spPr>
+          <a:xfrm>
+            <a:off x="640080" y="3931920"/>
+            <a:ext cx="3611880" cy="484632"/>
+          </a:xfrm>
+          <a:prstGeom prst="rect">
+            <a:avLst/>
+          </a:prstGeom>
+          <a:noFill/>
+          <a:ln/>
+        </p:spPr>
+        <p:txBody>
+          <a:bodyPr wrap="square" lIns="0" tIns="0" rIns="0" bIns="0" rtlCol="0" anchor="t"/>
+          <a:lstStyle/>
+          <a:p>
+            <a:pPr indent="0" marL="0">
+              <a:spcAft>
+                <a:spcPts val="400"/>
+              </a:spcAft>
+              <a:buNone/>
+            </a:pPr>
+            <a:r>
+              <a:rPr lang="en-US" sz="1400" dirty="0">
+                <a:solidFill>
+                  <a:schemeClr val="tx1"/>
+                </a:solidFill>
+              </a:rPr>
+              <a:t>TreeMap mit allen Konten, Top 5 / Bottom 5</a:t>
+            </a:r>
+            <a:endParaRPr lang="en-US" sz="1400" dirty="0"/>
+          </a:p>
+        </p:txBody>
+      </p:sp>
+      <p:sp>
+        <p:nvSpPr>
+          <p:cNvPr id="24" name="Karte Booking"/>
+          <p:cNvSpPr/>
+          <p:nvPr/>
+        </p:nvSpPr>
+        <p:spPr>
+          <a:xfrm>
+            <a:off x="4709160" y="3200400"/>
+            <a:ext cx="3977640" cy="1325880"/>
+          </a:xfrm>
+          <a:prstGeom prst="roundRect">
+            <a:avLst>
+              <a:gd name="adj" fmla="val 5517"/>
+            </a:avLst>
+          </a:prstGeom>
+          <a:solidFill>
+            <a:schemeClr val="bg2"/>
+          </a:solidFill>
+          <a:ln w="12700">
+            <a:solidFill>
+              <a:schemeClr val="bg2"/>
+            </a:solidFill>
+            <a:prstDash val="solid"/>
+          </a:ln>
+        </p:spPr>
+      </p:sp>
+      <p:sp>
+        <p:nvSpPr>
+          <p:cNvPr id="25" name="Badge b"/>
+          <p:cNvSpPr/>
+          <p:nvPr/>
+        </p:nvSpPr>
+        <p:spPr>
+          <a:xfrm>
+            <a:off x="4892040" y="3383280"/>
+            <a:ext cx="384048" cy="384048"/>
+          </a:xfrm>
+          <a:prstGeom prst="ellipse">
+            <a:avLst/>
+          </a:prstGeom>
+          <a:solidFill>
+            <a:schemeClr val="accent3"/>
+          </a:solidFill>
+          <a:ln w="12700">
+            <a:solidFill>
+              <a:schemeClr val="accent3"/>
+            </a:solidFill>
+            <a:prstDash val="solid"/>
+          </a:ln>
+        </p:spPr>
+      </p:sp>
+      <p:sp>
+        <p:nvSpPr>
+          <p:cNvPr id="26" name="Text 23"/>
+          <p:cNvSpPr txBox="1"/>
+          <p:nvPr/>
+        </p:nvSpPr>
+        <p:spPr>
+          <a:xfrm>
+            <a:off x="4892040" y="3383280"/>
+            <a:ext cx="384048" cy="384048"/>
+          </a:xfrm>
+          <a:prstGeom prst="rect">
+            <a:avLst/>
+          </a:prstGeom>
+          <a:noFill/>
+          <a:ln/>
+        </p:spPr>
+        <p:txBody>
+          <a:bodyPr wrap="square" lIns="0" tIns="0" rIns="0" bIns="0" rtlCol="0" anchor="ctr"/>
+          <a:lstStyle/>
+          <a:p>
+            <a:pPr algn="ctr" indent="0" marL="0">
+              <a:buNone/>
+            </a:pPr>
+            <a:r>
+              <a:rPr lang="en-US" sz="1400" b="1" dirty="0">
+                <a:solidFill>
+                  <a:schemeClr val="bg1"/>
+                </a:solidFill>
+              </a:rPr>
+              <a:t>b</a:t>
+            </a:r>
+            <a:endParaRPr lang="en-US" sz="1400" dirty="0"/>
+          </a:p>
+        </p:txBody>
+      </p:sp>
+      <p:sp>
+        <p:nvSpPr>
+          <p:cNvPr id="27" name="Text 24"/>
+          <p:cNvSpPr txBox="1"/>
+          <p:nvPr/>
+        </p:nvSpPr>
+        <p:spPr>
+          <a:xfrm>
+            <a:off x="5394960" y="3355848"/>
+            <a:ext cx="3154680" cy="438912"/>
+          </a:xfrm>
+          <a:prstGeom prst="rect">
+            <a:avLst/>
+          </a:prstGeom>
+          <a:noFill/>
+          <a:ln/>
+        </p:spPr>
+        <p:txBody>
+          <a:bodyPr wrap="square" lIns="0" tIns="0" rIns="0" bIns="0" rtlCol="0" anchor="ctr">
+            <a:normAutofit/>
+          </a:bodyPr>
+          <a:lstStyle/>
+          <a:p>
+            <a:pPr indent="0" marL="0">
+              <a:buNone/>
+            </a:pPr>
+            <a:r>
+              <a:rPr lang="en-US" sz="1600" b="1" dirty="0">
+                <a:solidFill>
+                  <a:schemeClr val="tx2"/>
+                </a:solidFill>
+              </a:rPr>
+              <a:t>Booking</a:t>
+            </a:r>
+            <a:endParaRPr lang="en-US" sz="1600" dirty="0"/>
+          </a:p>
+        </p:txBody>
+      </p:sp>
+      <p:sp>
+        <p:nvSpPr>
+          <p:cNvPr id="28" name="Text 25"/>
+          <p:cNvSpPr txBox="1"/>
+          <p:nvPr/>
+        </p:nvSpPr>
+        <p:spPr>
+          <a:xfrm>
+            <a:off x="4892040" y="3931920"/>
+            <a:ext cx="3611880" cy="484632"/>
+          </a:xfrm>
+          <a:prstGeom prst="rect">
+            <a:avLst/>
+          </a:prstGeom>
+          <a:noFill/>
+          <a:ln/>
+        </p:spPr>
+        <p:txBody>
+          <a:bodyPr wrap="square" lIns="0" tIns="0" rIns="0" bIns="0" rtlCol="0" anchor="t"/>
+          <a:lstStyle/>
+          <a:p>
+            <a:pPr indent="0" marL="0">
+              <a:spcAft>
+                <a:spcPts val="400"/>
+              </a:spcAft>
+              <a:buNone/>
+            </a:pPr>
+            <a:r>
+              <a:rPr lang="en-US" sz="1400" dirty="0">
+                <a:solidFill>
+                  <a:schemeClr val="tx1"/>
+                </a:solidFill>
+              </a:rPr>
+              <a:t>Datum + Betrag, Abhebungen negativ</a:t>
+            </a:r>
+            <a:endParaRPr lang="en-US" sz="1400" dirty="0"/>
+          </a:p>
+        </p:txBody>
+      </p:sp>
+      <p:sp>
+        <p:nvSpPr>
+          <p:cNvPr id="25" name="Slide Number Placeholder 0"/>
+          <p:cNvSpPr>
+            <a:spLocks noGrp="1"/>
+          </p:cNvSpPr>
+          <p:nvPr>
+            <p:ph type="sldNum" sz="quarter" idx="4294967295"/>
+          </p:nvPr>
+        </p:nvSpPr>
+        <p:spPr>
+          <a:xfrm>
+            <a:off x="8229600" y="4754880"/>
+            <a:ext cx="457200" cy="228600"/>
+          </a:xfrm>
+          <a:prstGeom prst="rect">
+            <a:avLst/>
+          </a:prstGeom>
+          <a:extLst>
+            <a:ext uri="{C572A759-6A51-4108-AA02-DFA0A04FC94B}">
+              <ma14:wrappingTextBoxFlag xmlns:ma14="http://schemas.microsoft.com/office/mac/drawingml/2011/main" val="0"/>
+            </a:ext>
+          </a:extLst>
+        </p:spPr>
+        <p:txBody>
+          <a:bodyPr/>
+          <a:lstStyle>
+            <a:lvl1pPr>
+              <a:defRPr sz="1000">
+                <a:solidFill>
+                  <a:schemeClr val="accent5"/>
+                </a:solidFill>
+              </a:defRPr>
+            </a:lvl1pPr>
+          </a:lstStyle>
+          <a:p>
+            <a:pPr algn="r"/>
+            <a:fld id="{F7021451-1387-4CA6-816F-3879F97B5CBC}" type="slidenum">
+              <a:rPr b="0" lang="en-US"/>
               <a:t>4</a:t>
             </a:fld>
             <a:endParaRPr lang="en-US"/>
@@ -4657,7 +4664,7 @@
                 <a:ea typeface="Cambria" pitchFamily="34" charset="-122"/>
                 <a:cs typeface="Cambria" pitchFamily="34" charset="-120"/>
               </a:rPr>
-              <a:t>Aufgabe 3: Aufbau der Bank-Simulation</a:t>
+              <a:t>Aufgabe 4: Unit-Tests und Coverage</a:t>
             </a:r>
             <a:endParaRPr lang="en-US" sz="2800" dirty="0"/>
           </a:p>
@@ -4665,18 +4672,18 @@
       </p:sp>
       <p:sp>
         <p:nvSpPr>
-          <p:cNvPr id="4" name="Karte SavingsAccount"/>
+          <p:cNvPr id="4" name="Kennzahl Tests grün"/>
           <p:cNvSpPr/>
           <p:nvPr/>
         </p:nvSpPr>
         <p:spPr>
           <a:xfrm>
-            <a:off x="457200" y="1097280"/>
-            <a:ext cx="2560320" cy="1828800"/>
+            <a:off x="457200" y="1051560"/>
+            <a:ext cx="2560320" cy="1371600"/>
           </a:xfrm>
           <a:prstGeom prst="roundRect">
             <a:avLst>
-              <a:gd name="adj" fmla="val 4000"/>
+              <a:gd name="adj" fmla="val 5333"/>
             </a:avLst>
           </a:prstGeom>
           <a:solidFill>
@@ -4692,28 +4699,42 @@
       </p:sp>
       <p:sp>
         <p:nvSpPr>
-          <p:cNvPr id="5" name="Badge 1"/>
-          <p:cNvSpPr/>
+          <p:cNvPr id="5" name="Text 2"/>
+          <p:cNvSpPr txBox="1"/>
           <p:nvPr/>
         </p:nvSpPr>
         <p:spPr>
           <a:xfrm>
-            <a:off x="640080" y="1280160"/>
-            <a:ext cx="384048" cy="384048"/>
-          </a:xfrm>
-          <a:prstGeom prst="ellipse">
-            <a:avLst/>
-          </a:prstGeom>
-          <a:solidFill>
-            <a:schemeClr val="accent3"/>
-          </a:solidFill>
-          <a:ln w="12700">
-            <a:solidFill>
-              <a:schemeClr val="accent3"/>
-            </a:solidFill>
-            <a:prstDash val="solid"/>
-          </a:ln>
-        </p:spPr>
+            <a:off x="457200" y="1143000"/>
+            <a:ext cx="2560320" cy="777240"/>
+          </a:xfrm>
+          <a:prstGeom prst="rect">
+            <a:avLst/>
+          </a:prstGeom>
+          <a:noFill/>
+          <a:ln/>
+        </p:spPr>
+        <p:txBody>
+          <a:bodyPr wrap="square" lIns="0" tIns="0" rIns="0" bIns="0" rtlCol="0" anchor="ctr"/>
+          <a:lstStyle/>
+          <a:p>
+            <a:pPr algn="ctr" indent="0" marL="0">
+              <a:buNone/>
+            </a:pPr>
+            <a:r>
+              <a:rPr lang="en-US" sz="3600" b="1" dirty="0">
+                <a:solidFill>
+                  <a:schemeClr val="accent1"/>
+                </a:solidFill>
+                <a:latin typeface="Cambria" pitchFamily="34" charset="0"/>
+                <a:ea typeface="Cambria" pitchFamily="34" charset="-122"/>
+                <a:cs typeface="Cambria" pitchFamily="34" charset="-120"/>
+              </a:rPr>
+              <a:t>40</a:t>
+            </a:r>
+            <a:endParaRPr lang="en-US" sz="3600" dirty="0"/>
+          </a:p>
+        </p:txBody>
       </p:sp>
       <p:sp>
         <p:nvSpPr>
@@ -4723,8 +4744,8 @@
         </p:nvSpPr>
         <p:spPr>
           <a:xfrm>
-            <a:off x="640080" y="1280160"/>
-            <a:ext cx="384048" cy="384048"/>
+            <a:off x="548640" y="1920240"/>
+            <a:ext cx="2377440" cy="457200"/>
           </a:xfrm>
           <a:prstGeom prst="rect">
             <a:avLst/>
@@ -4733,115 +4754,38 @@
           <a:ln/>
         </p:spPr>
         <p:txBody>
-          <a:bodyPr wrap="square" lIns="0" tIns="0" rIns="0" bIns="0" rtlCol="0" anchor="ctr"/>
-          <a:lstStyle/>
-          <a:p>
-            <a:pPr algn="ctr" indent="0" marL="0">
-              <a:buNone/>
-            </a:pPr>
-            <a:r>
-              <a:rPr lang="en-US" sz="1400" b="1" dirty="0">
-                <a:solidFill>
-                  <a:schemeClr val="bg1"/>
-                </a:solidFill>
-              </a:rPr>
-              <a:t>1</a:t>
-            </a:r>
-            <a:endParaRPr lang="en-US" sz="1400" dirty="0"/>
-          </a:p>
-        </p:txBody>
-      </p:sp>
-      <p:sp>
-        <p:nvSpPr>
-          <p:cNvPr id="7" name="Text 4"/>
-          <p:cNvSpPr txBox="1"/>
-          <p:nvPr/>
-        </p:nvSpPr>
-        <p:spPr>
-          <a:xfrm>
-            <a:off x="1143000" y="1252728"/>
-            <a:ext cx="1737360" cy="438912"/>
-          </a:xfrm>
-          <a:prstGeom prst="rect">
-            <a:avLst/>
-          </a:prstGeom>
-          <a:noFill/>
-          <a:ln/>
-        </p:spPr>
-        <p:txBody>
-          <a:bodyPr wrap="square" lIns="0" tIns="0" rIns="0" bIns="0" rtlCol="0" anchor="ctr">
-            <a:normAutofit/>
-          </a:bodyPr>
-          <a:lstStyle/>
-          <a:p>
-            <a:pPr indent="0" marL="0">
-              <a:buNone/>
-            </a:pPr>
-            <a:r>
-              <a:rPr lang="en-US" sz="1600" b="1" dirty="0">
-                <a:solidFill>
-                  <a:schemeClr val="tx2"/>
-                </a:solidFill>
-              </a:rPr>
-              <a:t>SavingsAccount</a:t>
-            </a:r>
-            <a:endParaRPr lang="en-US" sz="1600" dirty="0"/>
-          </a:p>
-        </p:txBody>
-      </p:sp>
-      <p:sp>
-        <p:nvSpPr>
-          <p:cNvPr id="8" name="Text 5"/>
-          <p:cNvSpPr txBox="1"/>
-          <p:nvPr/>
-        </p:nvSpPr>
-        <p:spPr>
-          <a:xfrm>
-            <a:off x="640080" y="1828800"/>
-            <a:ext cx="2194560" cy="987552"/>
-          </a:xfrm>
-          <a:prstGeom prst="rect">
-            <a:avLst/>
-          </a:prstGeom>
-          <a:noFill/>
-          <a:ln/>
-        </p:spPr>
-        <p:txBody>
           <a:bodyPr wrap="square" lIns="0" tIns="0" rIns="0" bIns="0" rtlCol="0" anchor="t"/>
           <a:lstStyle/>
           <a:p>
-            <a:pPr indent="0" marL="0">
-              <a:spcAft>
-                <a:spcPts val="400"/>
-              </a:spcAft>
-              <a:buNone/>
-            </a:pPr>
-            <a:r>
-              <a:rPr lang="en-US" sz="1400" dirty="0">
+            <a:pPr algn="ctr" indent="0" marL="0">
+              <a:buNone/>
+            </a:pPr>
+            <a:r>
+              <a:rPr lang="en-US" sz="1200" dirty="0">
                 <a:solidFill>
                   <a:schemeClr val="tx1"/>
                 </a:solidFill>
               </a:rPr>
-              <a:t>Kontostand nie unter 0</a:t>
-            </a:r>
-            <a:endParaRPr lang="en-US" sz="1400" dirty="0"/>
-          </a:p>
-        </p:txBody>
-      </p:sp>
-      <p:sp>
-        <p:nvSpPr>
-          <p:cNvPr id="9" name="Karte PromoYouthSavings"/>
+              <a:t>Tests grün</a:t>
+            </a:r>
+            <a:endParaRPr lang="en-US" sz="1200" dirty="0"/>
+          </a:p>
+        </p:txBody>
+      </p:sp>
+      <p:sp>
+        <p:nvSpPr>
+          <p:cNvPr id="7" name="Kennzahl Account, Booking, Konten"/>
           <p:cNvSpPr/>
           <p:nvPr/>
         </p:nvSpPr>
         <p:spPr>
           <a:xfrm>
-            <a:off x="3291840" y="1097280"/>
-            <a:ext cx="2560320" cy="1828800"/>
+            <a:off x="3291840" y="1051560"/>
+            <a:ext cx="2560320" cy="1371600"/>
           </a:xfrm>
           <a:prstGeom prst="roundRect">
             <a:avLst>
-              <a:gd name="adj" fmla="val 4000"/>
+              <a:gd name="adj" fmla="val 5333"/>
             </a:avLst>
           </a:prstGeom>
           <a:solidFill>
@@ -4857,156 +4801,93 @@
       </p:sp>
       <p:sp>
         <p:nvSpPr>
-          <p:cNvPr id="10" name="Badge 2"/>
+          <p:cNvPr id="8" name="Text 5"/>
+          <p:cNvSpPr txBox="1"/>
+          <p:nvPr/>
+        </p:nvSpPr>
+        <p:spPr>
+          <a:xfrm>
+            <a:off x="3291840" y="1143000"/>
+            <a:ext cx="2560320" cy="777240"/>
+          </a:xfrm>
+          <a:prstGeom prst="rect">
+            <a:avLst/>
+          </a:prstGeom>
+          <a:noFill/>
+          <a:ln/>
+        </p:spPr>
+        <p:txBody>
+          <a:bodyPr wrap="square" lIns="0" tIns="0" rIns="0" bIns="0" rtlCol="0" anchor="ctr"/>
+          <a:lstStyle/>
+          <a:p>
+            <a:pPr algn="ctr" indent="0" marL="0">
+              <a:buNone/>
+            </a:pPr>
+            <a:r>
+              <a:rPr lang="en-US" sz="3600" b="1" dirty="0">
+                <a:solidFill>
+                  <a:schemeClr val="accent1"/>
+                </a:solidFill>
+                <a:latin typeface="Cambria" pitchFamily="34" charset="0"/>
+                <a:ea typeface="Cambria" pitchFamily="34" charset="-122"/>
+                <a:cs typeface="Cambria" pitchFamily="34" charset="-120"/>
+              </a:rPr>
+              <a:t>100 %</a:t>
+            </a:r>
+            <a:endParaRPr lang="en-US" sz="3600" dirty="0"/>
+          </a:p>
+        </p:txBody>
+      </p:sp>
+      <p:sp>
+        <p:nvSpPr>
+          <p:cNvPr id="9" name="Text 6"/>
+          <p:cNvSpPr txBox="1"/>
+          <p:nvPr/>
+        </p:nvSpPr>
+        <p:spPr>
+          <a:xfrm>
+            <a:off x="3383280" y="1920240"/>
+            <a:ext cx="2377440" cy="457200"/>
+          </a:xfrm>
+          <a:prstGeom prst="rect">
+            <a:avLst/>
+          </a:prstGeom>
+          <a:noFill/>
+          <a:ln/>
+        </p:spPr>
+        <p:txBody>
+          <a:bodyPr wrap="square" lIns="0" tIns="0" rIns="0" bIns="0" rtlCol="0" anchor="t"/>
+          <a:lstStyle/>
+          <a:p>
+            <a:pPr algn="ctr" indent="0" marL="0">
+              <a:buNone/>
+            </a:pPr>
+            <a:r>
+              <a:rPr lang="en-US" sz="1200" dirty="0">
+                <a:solidFill>
+                  <a:schemeClr val="tx1"/>
+                </a:solidFill>
+              </a:rPr>
+              <a:t>Account, Booking, Konten</a:t>
+            </a:r>
+            <a:endParaRPr lang="en-US" sz="1200" dirty="0"/>
+          </a:p>
+        </p:txBody>
+      </p:sp>
+      <p:sp>
+        <p:nvSpPr>
+          <p:cNvPr id="10" name="Kennzahl Bank"/>
           <p:cNvSpPr/>
           <p:nvPr/>
         </p:nvSpPr>
         <p:spPr>
           <a:xfrm>
-            <a:off x="3474720" y="1280160"/>
-            <a:ext cx="384048" cy="384048"/>
-          </a:xfrm>
-          <a:prstGeom prst="ellipse">
-            <a:avLst/>
-          </a:prstGeom>
-          <a:solidFill>
-            <a:schemeClr val="accent3"/>
-          </a:solidFill>
-          <a:ln w="12700">
-            <a:solidFill>
-              <a:schemeClr val="accent3"/>
-            </a:solidFill>
-            <a:prstDash val="solid"/>
-          </a:ln>
-        </p:spPr>
-      </p:sp>
-      <p:sp>
-        <p:nvSpPr>
-          <p:cNvPr id="11" name="Text 8"/>
-          <p:cNvSpPr txBox="1"/>
-          <p:nvPr/>
-        </p:nvSpPr>
-        <p:spPr>
-          <a:xfrm>
-            <a:off x="3474720" y="1280160"/>
-            <a:ext cx="384048" cy="384048"/>
-          </a:xfrm>
-          <a:prstGeom prst="rect">
-            <a:avLst/>
-          </a:prstGeom>
-          <a:noFill/>
-          <a:ln/>
-        </p:spPr>
-        <p:txBody>
-          <a:bodyPr wrap="square" lIns="0" tIns="0" rIns="0" bIns="0" rtlCol="0" anchor="ctr"/>
-          <a:lstStyle/>
-          <a:p>
-            <a:pPr algn="ctr" indent="0" marL="0">
-              <a:buNone/>
-            </a:pPr>
-            <a:r>
-              <a:rPr lang="en-US" sz="1400" b="1" dirty="0">
-                <a:solidFill>
-                  <a:schemeClr val="bg1"/>
-                </a:solidFill>
-              </a:rPr>
-              <a:t>2</a:t>
-            </a:r>
-            <a:endParaRPr lang="en-US" sz="1400" dirty="0"/>
-          </a:p>
-        </p:txBody>
-      </p:sp>
-      <p:sp>
-        <p:nvSpPr>
-          <p:cNvPr id="12" name="Text 9"/>
-          <p:cNvSpPr txBox="1"/>
-          <p:nvPr/>
-        </p:nvSpPr>
-        <p:spPr>
-          <a:xfrm>
-            <a:off x="3977640" y="1252728"/>
-            <a:ext cx="1737360" cy="438912"/>
-          </a:xfrm>
-          <a:prstGeom prst="rect">
-            <a:avLst/>
-          </a:prstGeom>
-          <a:noFill/>
-          <a:ln/>
-        </p:spPr>
-        <p:txBody>
-          <a:bodyPr wrap="square" lIns="0" tIns="0" rIns="0" bIns="0" rtlCol="0" anchor="ctr">
-            <a:normAutofit/>
-          </a:bodyPr>
-          <a:lstStyle/>
-          <a:p>
-            <a:pPr indent="0" marL="0">
-              <a:buNone/>
-            </a:pPr>
-            <a:r>
-              <a:rPr lang="en-US" sz="1600" b="1" dirty="0">
-                <a:solidFill>
-                  <a:schemeClr val="tx2"/>
-                </a:solidFill>
-              </a:rPr>
-              <a:t>PromoYouthSavings</a:t>
-            </a:r>
-            <a:endParaRPr lang="en-US" sz="1600" dirty="0"/>
-          </a:p>
-        </p:txBody>
-      </p:sp>
-      <p:sp>
-        <p:nvSpPr>
-          <p:cNvPr id="13" name="Text 10"/>
-          <p:cNvSpPr txBox="1"/>
-          <p:nvPr/>
-        </p:nvSpPr>
-        <p:spPr>
-          <a:xfrm>
-            <a:off x="3474720" y="1828800"/>
-            <a:ext cx="2194560" cy="987552"/>
-          </a:xfrm>
-          <a:prstGeom prst="rect">
-            <a:avLst/>
-          </a:prstGeom>
-          <a:noFill/>
-          <a:ln/>
-        </p:spPr>
-        <p:txBody>
-          <a:bodyPr wrap="square" lIns="0" tIns="0" rIns="0" bIns="0" rtlCol="0" anchor="t"/>
-          <a:lstStyle/>
-          <a:p>
-            <a:pPr indent="0" marL="0">
-              <a:spcAft>
-                <a:spcPts val="400"/>
-              </a:spcAft>
-              <a:buNone/>
-            </a:pPr>
-            <a:r>
-              <a:rPr lang="en-US" sz="1400" dirty="0">
-                <a:solidFill>
-                  <a:schemeClr val="tx1"/>
-                </a:solidFill>
-              </a:rPr>
-              <a:t>+1 % Bonus bei jeder Einzahlung</a:t>
-            </a:r>
-            <a:endParaRPr lang="en-US" sz="1400" dirty="0"/>
-          </a:p>
-        </p:txBody>
-      </p:sp>
-      <p:sp>
-        <p:nvSpPr>
-          <p:cNvPr id="14" name="Karte SalaryAccount"/>
-          <p:cNvSpPr/>
-          <p:nvPr/>
-        </p:nvSpPr>
-        <p:spPr>
-          <a:xfrm>
-            <a:off x="6126480" y="1097280"/>
-            <a:ext cx="2560320" cy="1828800"/>
+            <a:off x="6126480" y="1051560"/>
+            <a:ext cx="2560320" cy="1371600"/>
           </a:xfrm>
           <a:prstGeom prst="roundRect">
             <a:avLst>
-              <a:gd name="adj" fmla="val 4000"/>
+              <a:gd name="adj" fmla="val 5333"/>
             </a:avLst>
           </a:prstGeom>
           <a:solidFill>
@@ -5022,24 +4903,101 @@
       </p:sp>
       <p:sp>
         <p:nvSpPr>
-          <p:cNvPr id="15" name="Badge 3"/>
+          <p:cNvPr id="11" name="Text 8"/>
+          <p:cNvSpPr txBox="1"/>
+          <p:nvPr/>
+        </p:nvSpPr>
+        <p:spPr>
+          <a:xfrm>
+            <a:off x="6126480" y="1143000"/>
+            <a:ext cx="2560320" cy="777240"/>
+          </a:xfrm>
+          <a:prstGeom prst="rect">
+            <a:avLst/>
+          </a:prstGeom>
+          <a:noFill/>
+          <a:ln/>
+        </p:spPr>
+        <p:txBody>
+          <a:bodyPr wrap="square" lIns="0" tIns="0" rIns="0" bIns="0" rtlCol="0" anchor="ctr"/>
+          <a:lstStyle/>
+          <a:p>
+            <a:pPr algn="ctr" indent="0" marL="0">
+              <a:buNone/>
+            </a:pPr>
+            <a:r>
+              <a:rPr lang="en-US" sz="3600" b="1" dirty="0">
+                <a:solidFill>
+                  <a:schemeClr val="accent1"/>
+                </a:solidFill>
+                <a:latin typeface="Cambria" pitchFamily="34" charset="0"/>
+                <a:ea typeface="Cambria" pitchFamily="34" charset="-122"/>
+                <a:cs typeface="Cambria" pitchFamily="34" charset="-120"/>
+              </a:rPr>
+              <a:t>97 %</a:t>
+            </a:r>
+            <a:endParaRPr lang="en-US" sz="3600" dirty="0"/>
+          </a:p>
+        </p:txBody>
+      </p:sp>
+      <p:sp>
+        <p:nvSpPr>
+          <p:cNvPr id="12" name="Text 9"/>
+          <p:cNvSpPr txBox="1"/>
+          <p:nvPr/>
+        </p:nvSpPr>
+        <p:spPr>
+          <a:xfrm>
+            <a:off x="6217920" y="1920240"/>
+            <a:ext cx="2377440" cy="457200"/>
+          </a:xfrm>
+          <a:prstGeom prst="rect">
+            <a:avLst/>
+          </a:prstGeom>
+          <a:noFill/>
+          <a:ln/>
+        </p:spPr>
+        <p:txBody>
+          <a:bodyPr wrap="square" lIns="0" tIns="0" rIns="0" bIns="0" rtlCol="0" anchor="t"/>
+          <a:lstStyle/>
+          <a:p>
+            <a:pPr algn="ctr" indent="0" marL="0">
+              <a:buNone/>
+            </a:pPr>
+            <a:r>
+              <a:rPr lang="en-US" sz="1200" dirty="0">
+                <a:solidFill>
+                  <a:schemeClr val="tx1"/>
+                </a:solidFill>
+              </a:rPr>
+              <a:t>Bank</a:t>
+            </a:r>
+            <a:endParaRPr lang="en-US" sz="1200" dirty="0"/>
+          </a:p>
+        </p:txBody>
+      </p:sp>
+      <p:sp>
+        <p:nvSpPr>
+          <p:cNvPr id="13" name="Code Box"/>
           <p:cNvSpPr/>
           <p:nvPr/>
         </p:nvSpPr>
         <p:spPr>
           <a:xfrm>
-            <a:off x="6309360" y="1280160"/>
-            <a:ext cx="384048" cy="384048"/>
-          </a:xfrm>
-          <a:prstGeom prst="ellipse">
-            <a:avLst/>
+            <a:off x="457200" y="2697480"/>
+            <a:ext cx="8229600" cy="1828800"/>
+          </a:xfrm>
+          <a:prstGeom prst="roundRect">
+            <a:avLst>
+              <a:gd name="adj" fmla="val 4000"/>
+            </a:avLst>
           </a:prstGeom>
           <a:solidFill>
-            <a:schemeClr val="accent3"/>
+            <a:schemeClr val="tx1"/>
           </a:solidFill>
           <a:ln w="12700">
             <a:solidFill>
-              <a:schemeClr val="accent3"/>
+              <a:schemeClr val="tx1"/>
             </a:solidFill>
             <a:prstDash val="solid"/>
           </a:ln>
@@ -5047,14 +5005,14 @@
       </p:sp>
       <p:sp>
         <p:nvSpPr>
-          <p:cNvPr id="16" name="Text 13"/>
+          <p:cNvPr id="14" name="Text 11"/>
           <p:cNvSpPr txBox="1"/>
           <p:nvPr/>
         </p:nvSpPr>
         <p:spPr>
           <a:xfrm>
-            <a:off x="6309360" y="1280160"/>
-            <a:ext cx="384048" cy="384048"/>
+            <a:off x="640080" y="2807208"/>
+            <a:ext cx="7863840" cy="274320"/>
           </a:xfrm>
           <a:prstGeom prst="rect">
             <a:avLst/>
@@ -5066,31 +5024,31 @@
           <a:bodyPr wrap="square" lIns="0" tIns="0" rIns="0" bIns="0" rtlCol="0" anchor="ctr"/>
           <a:lstStyle/>
           <a:p>
-            <a:pPr algn="ctr" indent="0" marL="0">
-              <a:buNone/>
-            </a:pPr>
-            <a:r>
-              <a:rPr lang="en-US" sz="1400" b="1" dirty="0">
-                <a:solidFill>
-                  <a:schemeClr val="bg1"/>
+            <a:pPr indent="0" marL="0">
+              <a:buNone/>
+            </a:pPr>
+            <a:r>
+              <a:rPr lang="en-US" sz="1100" b="1" dirty="0">
+                <a:solidFill>
+                  <a:schemeClr val="accent6"/>
                 </a:solidFill>
               </a:rPr>
-              <a:t>3</a:t>
-            </a:r>
-            <a:endParaRPr lang="en-US" sz="1400" dirty="0"/>
-          </a:p>
-        </p:txBody>
-      </p:sp>
-      <p:sp>
-        <p:nvSpPr>
-          <p:cNvPr id="17" name="Text 14"/>
+              <a:t>Ausgabe von print() testen</a:t>
+            </a:r>
+            <a:endParaRPr lang="en-US" sz="1100" dirty="0"/>
+          </a:p>
+        </p:txBody>
+      </p:sp>
+      <p:sp>
+        <p:nvSpPr>
+          <p:cNvPr id="15" name="Code"/>
           <p:cNvSpPr txBox="1"/>
           <p:nvPr/>
         </p:nvSpPr>
         <p:spPr>
           <a:xfrm>
-            <a:off x="6812280" y="1252728"/>
-            <a:ext cx="1737360" cy="438912"/>
+            <a:off x="640080" y="3108960"/>
+            <a:ext cx="7863840" cy="1280160"/>
           </a:xfrm>
           <a:prstGeom prst="rect">
             <a:avLst/>
@@ -5099,392 +5057,81 @@
           <a:ln/>
         </p:spPr>
         <p:txBody>
-          <a:bodyPr wrap="square" lIns="0" tIns="0" rIns="0" bIns="0" rtlCol="0" anchor="ctr">
-            <a:normAutofit/>
-          </a:bodyPr>
-          <a:lstStyle/>
-          <a:p>
-            <a:pPr indent="0" marL="0">
-              <a:buNone/>
-            </a:pPr>
-            <a:r>
-              <a:rPr lang="en-US" sz="1600" b="1" dirty="0">
-                <a:solidFill>
-                  <a:schemeClr val="tx2"/>
-                </a:solidFill>
-              </a:rPr>
-              <a:t>SalaryAccount</a:t>
-            </a:r>
-            <a:endParaRPr lang="en-US" sz="1600" dirty="0"/>
-          </a:p>
-        </p:txBody>
-      </p:sp>
-      <p:sp>
-        <p:nvSpPr>
-          <p:cNvPr id="18" name="Text 15"/>
-          <p:cNvSpPr txBox="1"/>
-          <p:nvPr/>
-        </p:nvSpPr>
-        <p:spPr>
-          <a:xfrm>
-            <a:off x="6309360" y="1828800"/>
-            <a:ext cx="2194560" cy="987552"/>
-          </a:xfrm>
-          <a:prstGeom prst="rect">
-            <a:avLst/>
-          </a:prstGeom>
-          <a:noFill/>
-          <a:ln/>
-        </p:spPr>
-        <p:txBody>
           <a:bodyPr wrap="square" lIns="0" tIns="0" rIns="0" bIns="0" rtlCol="0" anchor="t"/>
           <a:lstStyle/>
           <a:p>
             <a:pPr indent="0" marL="0">
-              <a:spcAft>
-                <a:spcPts val="400"/>
-              </a:spcAft>
-              <a:buNone/>
-            </a:pPr>
-            <a:r>
-              <a:rPr lang="en-US" sz="1400" dirty="0">
-                <a:solidFill>
-                  <a:schemeClr val="tx1"/>
-                </a:solidFill>
+              <a:buNone/>
+            </a:pPr>
+            <a:r>
+              <a:rPr lang="en-US" sz="1300" dirty="0">
+                <a:solidFill>
+                  <a:schemeClr val="bg1"/>
+                </a:solidFill>
+                <a:latin typeface="Courier New" pitchFamily="34" charset="0"/>
+                <a:ea typeface="Courier New" pitchFamily="34" charset="-122"/>
+                <a:cs typeface="Courier New" pitchFamily="34" charset="-120"/>
               </a:rPr>
-              <a:t>Darf bis zur Kreditlimite ins Minus</a:t>
-            </a:r>
-            <a:endParaRPr lang="en-US" sz="1400" dirty="0"/>
-          </a:p>
-        </p:txBody>
-      </p:sp>
-      <p:sp>
-        <p:nvSpPr>
-          <p:cNvPr id="19" name="Karte Bank"/>
-          <p:cNvSpPr/>
-          <p:nvPr/>
-        </p:nvSpPr>
-        <p:spPr>
-          <a:xfrm>
-            <a:off x="457200" y="3200400"/>
-            <a:ext cx="3977640" cy="1325880"/>
-          </a:xfrm>
-          <a:prstGeom prst="roundRect">
-            <a:avLst>
-              <a:gd name="adj" fmla="val 5517"/>
-            </a:avLst>
-          </a:prstGeom>
-          <a:solidFill>
-            <a:schemeClr val="bg2"/>
-          </a:solidFill>
-          <a:ln w="12700">
-            <a:solidFill>
-              <a:schemeClr val="bg2"/>
-            </a:solidFill>
-            <a:prstDash val="solid"/>
-          </a:ln>
-        </p:spPr>
-      </p:sp>
-      <p:sp>
-        <p:nvSpPr>
-          <p:cNvPr id="20" name="Badge B"/>
-          <p:cNvSpPr/>
-          <p:nvPr/>
-        </p:nvSpPr>
-        <p:spPr>
-          <a:xfrm>
-            <a:off x="640080" y="3383280"/>
-            <a:ext cx="384048" cy="384048"/>
-          </a:xfrm>
-          <a:prstGeom prst="ellipse">
-            <a:avLst/>
-          </a:prstGeom>
-          <a:solidFill>
-            <a:schemeClr val="accent3"/>
-          </a:solidFill>
-          <a:ln w="12700">
-            <a:solidFill>
-              <a:schemeClr val="accent3"/>
-            </a:solidFill>
-            <a:prstDash val="solid"/>
-          </a:ln>
-        </p:spPr>
-      </p:sp>
-      <p:sp>
-        <p:nvSpPr>
-          <p:cNvPr id="21" name="Text 18"/>
-          <p:cNvSpPr txBox="1"/>
-          <p:nvPr/>
-        </p:nvSpPr>
-        <p:spPr>
-          <a:xfrm>
-            <a:off x="640080" y="3383280"/>
-            <a:ext cx="384048" cy="384048"/>
-          </a:xfrm>
-          <a:prstGeom prst="rect">
-            <a:avLst/>
-          </a:prstGeom>
-          <a:noFill/>
-          <a:ln/>
-        </p:spPr>
-        <p:txBody>
-          <a:bodyPr wrap="square" lIns="0" tIns="0" rIns="0" bIns="0" rtlCol="0" anchor="ctr"/>
-          <a:lstStyle/>
-          <a:p>
-            <a:pPr algn="ctr" indent="0" marL="0">
-              <a:buNone/>
-            </a:pPr>
-            <a:r>
-              <a:rPr lang="en-US" sz="1400" b="1" dirty="0">
+              <a:t>output = new ByteArrayOutputStream();</a:t>
+            </a:r>
+            <a:endParaRPr lang="en-US" sz="1300" dirty="0"/>
+          </a:p>
+          <a:p>
+            <a:pPr indent="0" marL="0">
+              <a:buNone/>
+            </a:pPr>
+            <a:r>
+              <a:rPr lang="en-US" sz="1300" dirty="0">
                 <a:solidFill>
                   <a:schemeClr val="bg1"/>
                 </a:solidFill>
+                <a:latin typeface="Courier New" pitchFamily="34" charset="0"/>
+                <a:ea typeface="Courier New" pitchFamily="34" charset="-122"/>
+                <a:cs typeface="Courier New" pitchFamily="34" charset="-120"/>
               </a:rPr>
-              <a:t>B</a:t>
-            </a:r>
-            <a:endParaRPr lang="en-US" sz="1400" dirty="0"/>
-          </a:p>
-        </p:txBody>
-      </p:sp>
-      <p:sp>
-        <p:nvSpPr>
-          <p:cNvPr id="22" name="Text 19"/>
-          <p:cNvSpPr txBox="1"/>
-          <p:nvPr/>
-        </p:nvSpPr>
-        <p:spPr>
-          <a:xfrm>
-            <a:off x="1143000" y="3355848"/>
-            <a:ext cx="3154680" cy="438912"/>
-          </a:xfrm>
-          <a:prstGeom prst="rect">
-            <a:avLst/>
-          </a:prstGeom>
-          <a:noFill/>
-          <a:ln/>
-        </p:spPr>
-        <p:txBody>
-          <a:bodyPr wrap="square" lIns="0" tIns="0" rIns="0" bIns="0" rtlCol="0" anchor="ctr">
-            <a:normAutofit/>
-          </a:bodyPr>
-          <a:lstStyle/>
+              <a:t>System.setOut(new PrintStream(output));</a:t>
+            </a:r>
+            <a:endParaRPr lang="en-US" sz="1300" dirty="0"/>
+          </a:p>
           <a:p>
             <a:pPr indent="0" marL="0">
               <a:buNone/>
             </a:pPr>
-            <a:r>
-              <a:rPr lang="en-US" sz="1600" b="1" dirty="0">
-                <a:solidFill>
-                  <a:schemeClr val="tx2"/>
-                </a:solidFill>
+            <a:endParaRPr lang="en-US" sz="1300" dirty="0"/>
+          </a:p>
+          <a:p>
+            <a:pPr indent="0" marL="0">
+              <a:buNone/>
+            </a:pPr>
+            <a:r>
+              <a:rPr lang="en-US" sz="1300" dirty="0">
+                <a:solidFill>
+                  <a:schemeClr val="bg1"/>
+                </a:solidFill>
+                <a:latin typeface="Courier New" pitchFamily="34" charset="0"/>
+                <a:ea typeface="Courier New" pitchFamily="34" charset="-122"/>
+                <a:cs typeface="Courier New" pitchFamily="34" charset="-120"/>
               </a:rPr>
-              <a:t>Bank</a:t>
-            </a:r>
-            <a:endParaRPr lang="en-US" sz="1600" dirty="0"/>
-          </a:p>
-        </p:txBody>
-      </p:sp>
-      <p:sp>
-        <p:nvSpPr>
-          <p:cNvPr id="23" name="Text 20"/>
-          <p:cNvSpPr txBox="1"/>
-          <p:nvPr/>
-        </p:nvSpPr>
-        <p:spPr>
-          <a:xfrm>
-            <a:off x="640080" y="3931920"/>
-            <a:ext cx="3611880" cy="484632"/>
-          </a:xfrm>
-          <a:prstGeom prst="rect">
-            <a:avLst/>
-          </a:prstGeom>
-          <a:noFill/>
-          <a:ln/>
-        </p:spPr>
-        <p:txBody>
-          <a:bodyPr wrap="square" lIns="0" tIns="0" rIns="0" bIns="0" rtlCol="0" anchor="t"/>
-          <a:lstStyle/>
+              <a:t>account.print();</a:t>
+            </a:r>
+            <a:endParaRPr lang="en-US" sz="1300" dirty="0"/>
+          </a:p>
           <a:p>
             <a:pPr indent="0" marL="0">
-              <a:spcAft>
-                <a:spcPts val="400"/>
-              </a:spcAft>
-              <a:buNone/>
-            </a:pPr>
-            <a:r>
-              <a:rPr lang="en-US" sz="1400" dirty="0">
-                <a:solidFill>
-                  <a:schemeClr val="tx1"/>
-                </a:solidFill>
+              <a:buNone/>
+            </a:pPr>
+            <a:r>
+              <a:rPr lang="en-US" sz="1300" dirty="0">
+                <a:solidFill>
+                  <a:schemeClr val="bg1"/>
+                </a:solidFill>
+                <a:latin typeface="Courier New" pitchFamily="34" charset="0"/>
+                <a:ea typeface="Courier New" pitchFamily="34" charset="-122"/>
+                <a:cs typeface="Courier New" pitchFamily="34" charset="-120"/>
               </a:rPr>
-              <a:t>TreeMap mit allen Konten, Top 5 / Bottom 5</a:t>
-            </a:r>
-            <a:endParaRPr lang="en-US" sz="1400" dirty="0"/>
-          </a:p>
-        </p:txBody>
-      </p:sp>
-      <p:sp>
-        <p:nvSpPr>
-          <p:cNvPr id="24" name="Karte Booking"/>
-          <p:cNvSpPr/>
-          <p:nvPr/>
-        </p:nvSpPr>
-        <p:spPr>
-          <a:xfrm>
-            <a:off x="4709160" y="3200400"/>
-            <a:ext cx="3977640" cy="1325880"/>
-          </a:xfrm>
-          <a:prstGeom prst="roundRect">
-            <a:avLst>
-              <a:gd name="adj" fmla="val 5517"/>
-            </a:avLst>
-          </a:prstGeom>
-          <a:solidFill>
-            <a:schemeClr val="bg2"/>
-          </a:solidFill>
-          <a:ln w="12700">
-            <a:solidFill>
-              <a:schemeClr val="bg2"/>
-            </a:solidFill>
-            <a:prstDash val="solid"/>
-          </a:ln>
-        </p:spPr>
-      </p:sp>
-      <p:sp>
-        <p:nvSpPr>
-          <p:cNvPr id="25" name="Badge b"/>
-          <p:cNvSpPr/>
-          <p:nvPr/>
-        </p:nvSpPr>
-        <p:spPr>
-          <a:xfrm>
-            <a:off x="4892040" y="3383280"/>
-            <a:ext cx="384048" cy="384048"/>
-          </a:xfrm>
-          <a:prstGeom prst="ellipse">
-            <a:avLst/>
-          </a:prstGeom>
-          <a:solidFill>
-            <a:schemeClr val="accent3"/>
-          </a:solidFill>
-          <a:ln w="12700">
-            <a:solidFill>
-              <a:schemeClr val="accent3"/>
-            </a:solidFill>
-            <a:prstDash val="solid"/>
-          </a:ln>
-        </p:spPr>
-      </p:sp>
-      <p:sp>
-        <p:nvSpPr>
-          <p:cNvPr id="26" name="Text 23"/>
-          <p:cNvSpPr txBox="1"/>
-          <p:nvPr/>
-        </p:nvSpPr>
-        <p:spPr>
-          <a:xfrm>
-            <a:off x="4892040" y="3383280"/>
-            <a:ext cx="384048" cy="384048"/>
-          </a:xfrm>
-          <a:prstGeom prst="rect">
-            <a:avLst/>
-          </a:prstGeom>
-          <a:noFill/>
-          <a:ln/>
-        </p:spPr>
-        <p:txBody>
-          <a:bodyPr wrap="square" lIns="0" tIns="0" rIns="0" bIns="0" rtlCol="0" anchor="ctr"/>
-          <a:lstStyle/>
-          <a:p>
-            <a:pPr algn="ctr" indent="0" marL="0">
-              <a:buNone/>
-            </a:pPr>
-            <a:r>
-              <a:rPr lang="en-US" sz="1400" b="1" dirty="0">
-                <a:solidFill>
-                  <a:schemeClr val="bg1"/>
-                </a:solidFill>
-              </a:rPr>
-              <a:t>b</a:t>
-            </a:r>
-            <a:endParaRPr lang="en-US" sz="1400" dirty="0"/>
-          </a:p>
-        </p:txBody>
-      </p:sp>
-      <p:sp>
-        <p:nvSpPr>
-          <p:cNvPr id="27" name="Text 24"/>
-          <p:cNvSpPr txBox="1"/>
-          <p:nvPr/>
-        </p:nvSpPr>
-        <p:spPr>
-          <a:xfrm>
-            <a:off x="5394960" y="3355848"/>
-            <a:ext cx="3154680" cy="438912"/>
-          </a:xfrm>
-          <a:prstGeom prst="rect">
-            <a:avLst/>
-          </a:prstGeom>
-          <a:noFill/>
-          <a:ln/>
-        </p:spPr>
-        <p:txBody>
-          <a:bodyPr wrap="square" lIns="0" tIns="0" rIns="0" bIns="0" rtlCol="0" anchor="ctr">
-            <a:normAutofit/>
-          </a:bodyPr>
-          <a:lstStyle/>
-          <a:p>
-            <a:pPr indent="0" marL="0">
-              <a:buNone/>
-            </a:pPr>
-            <a:r>
-              <a:rPr lang="en-US" sz="1600" b="1" dirty="0">
-                <a:solidFill>
-                  <a:schemeClr val="tx2"/>
-                </a:solidFill>
-              </a:rPr>
-              <a:t>Booking</a:t>
-            </a:r>
-            <a:endParaRPr lang="en-US" sz="1600" dirty="0"/>
-          </a:p>
-        </p:txBody>
-      </p:sp>
-      <p:sp>
-        <p:nvSpPr>
-          <p:cNvPr id="28" name="Text 25"/>
-          <p:cNvSpPr txBox="1"/>
-          <p:nvPr/>
-        </p:nvSpPr>
-        <p:spPr>
-          <a:xfrm>
-            <a:off x="4892040" y="3931920"/>
-            <a:ext cx="3611880" cy="484632"/>
-          </a:xfrm>
-          <a:prstGeom prst="rect">
-            <a:avLst/>
-          </a:prstGeom>
-          <a:noFill/>
-          <a:ln/>
-        </p:spPr>
-        <p:txBody>
-          <a:bodyPr wrap="square" lIns="0" tIns="0" rIns="0" bIns="0" rtlCol="0" anchor="t"/>
-          <a:lstStyle/>
-          <a:p>
-            <a:pPr indent="0" marL="0">
-              <a:spcAft>
-                <a:spcPts val="400"/>
-              </a:spcAft>
-              <a:buNone/>
-            </a:pPr>
-            <a:r>
-              <a:rPr lang="en-US" sz="1400" dirty="0">
-                <a:solidFill>
-                  <a:schemeClr val="tx1"/>
-                </a:solidFill>
-              </a:rPr>
-              <a:t>Datum + Betrag, Abhebungen negativ</a:t>
-            </a:r>
-            <a:endParaRPr lang="en-US" sz="1400" dirty="0"/>
+              <a:t>assertTrue(output.toString().contains("01.01.1970"));</a:t>
+            </a:r>
+            <a:endParaRPr lang="en-US" sz="1300" dirty="0"/>
           </a:p>
         </p:txBody>
       </p:sp>
@@ -5544,582 +5191,6 @@
 <file path=ppt/slides/slide6.xml><?xml version="1.0" encoding="utf-8"?>
 <p:sld xmlns:a="http://schemas.openxmlformats.org/drawingml/2006/main" xmlns:r="http://schemas.openxmlformats.org/officeDocument/2006/relationships" xmlns:p="http://schemas.openxmlformats.org/presentationml/2006/main">
   <p:cSld name="Slide 6">
-    <p:spTree>
-      <p:nvGrpSpPr>
-        <p:cNvPr id="1" name=""/>
-        <p:cNvGrpSpPr/>
-        <p:nvPr/>
-      </p:nvGrpSpPr>
-      <p:grpSpPr>
-        <a:xfrm>
-          <a:off x="0" y="0"/>
-          <a:ext cx="0" cy="0"/>
-          <a:chOff x="0" y="0"/>
-          <a:chExt cx="0" cy="0"/>
-        </a:xfrm>
-      </p:grpSpPr>
-      <p:sp>
-        <p:nvSpPr>
-          <p:cNvPr id="2" name="Text 0"/>
-          <p:cNvSpPr/>
-          <p:nvPr>
-            <p:ph idx="100" type="title" hasCustomPrompt="1"/>
-          </p:nvPr>
-        </p:nvSpPr>
-        <p:spPr>
-          <a:xfrm>
-            <a:off x="457200" y="274320"/>
-            <a:ext cx="8229600" cy="594360"/>
-          </a:xfrm>
-          <a:prstGeom prst="rect">
-            <a:avLst/>
-          </a:prstGeom>
-          <a:noFill/>
-          <a:ln/>
-        </p:spPr>
-        <p:txBody>
-          <a:bodyPr wrap="square" lIns="0" tIns="0" rIns="0" bIns="0" rtlCol="0" anchor="ctr"/>
-          <a:lstStyle/>
-          <a:p>
-            <a:pPr algn="l" indent="0" marL="0">
-              <a:buNone/>
-            </a:pPr>
-            <a:r>
-              <a:rPr lang="en-US" sz="2800" b="1" dirty="0">
-                <a:solidFill>
-                  <a:schemeClr val="tx2"/>
-                </a:solidFill>
-                <a:latin typeface="Cambria" pitchFamily="34" charset="0"/>
-                <a:ea typeface="Cambria" pitchFamily="34" charset="-122"/>
-                <a:cs typeface="Cambria" pitchFamily="34" charset="-120"/>
-              </a:rPr>
-              <a:t>Aufgabe 4: Unit-Tests und Coverage</a:t>
-            </a:r>
-            <a:endParaRPr lang="en-US" sz="2800" dirty="0"/>
-          </a:p>
-        </p:txBody>
-      </p:sp>
-      <p:sp>
-        <p:nvSpPr>
-          <p:cNvPr id="4" name="Kennzahl Tests grün"/>
-          <p:cNvSpPr/>
-          <p:nvPr/>
-        </p:nvSpPr>
-        <p:spPr>
-          <a:xfrm>
-            <a:off x="457200" y="1051560"/>
-            <a:ext cx="2560320" cy="1371600"/>
-          </a:xfrm>
-          <a:prstGeom prst="roundRect">
-            <a:avLst>
-              <a:gd name="adj" fmla="val 5333"/>
-            </a:avLst>
-          </a:prstGeom>
-          <a:solidFill>
-            <a:schemeClr val="bg2"/>
-          </a:solidFill>
-          <a:ln w="12700">
-            <a:solidFill>
-              <a:schemeClr val="bg2"/>
-            </a:solidFill>
-            <a:prstDash val="solid"/>
-          </a:ln>
-        </p:spPr>
-      </p:sp>
-      <p:sp>
-        <p:nvSpPr>
-          <p:cNvPr id="5" name="Text 2"/>
-          <p:cNvSpPr txBox="1"/>
-          <p:nvPr/>
-        </p:nvSpPr>
-        <p:spPr>
-          <a:xfrm>
-            <a:off x="457200" y="1143000"/>
-            <a:ext cx="2560320" cy="777240"/>
-          </a:xfrm>
-          <a:prstGeom prst="rect">
-            <a:avLst/>
-          </a:prstGeom>
-          <a:noFill/>
-          <a:ln/>
-        </p:spPr>
-        <p:txBody>
-          <a:bodyPr wrap="square" lIns="0" tIns="0" rIns="0" bIns="0" rtlCol="0" anchor="ctr"/>
-          <a:lstStyle/>
-          <a:p>
-            <a:pPr algn="ctr" indent="0" marL="0">
-              <a:buNone/>
-            </a:pPr>
-            <a:r>
-              <a:rPr lang="en-US" sz="3600" b="1" dirty="0">
-                <a:solidFill>
-                  <a:schemeClr val="accent1"/>
-                </a:solidFill>
-                <a:latin typeface="Cambria" pitchFamily="34" charset="0"/>
-                <a:ea typeface="Cambria" pitchFamily="34" charset="-122"/>
-                <a:cs typeface="Cambria" pitchFamily="34" charset="-120"/>
-              </a:rPr>
-              <a:t>40</a:t>
-            </a:r>
-            <a:endParaRPr lang="en-US" sz="3600" dirty="0"/>
-          </a:p>
-        </p:txBody>
-      </p:sp>
-      <p:sp>
-        <p:nvSpPr>
-          <p:cNvPr id="6" name="Text 3"/>
-          <p:cNvSpPr txBox="1"/>
-          <p:nvPr/>
-        </p:nvSpPr>
-        <p:spPr>
-          <a:xfrm>
-            <a:off x="548640" y="1920240"/>
-            <a:ext cx="2377440" cy="457200"/>
-          </a:xfrm>
-          <a:prstGeom prst="rect">
-            <a:avLst/>
-          </a:prstGeom>
-          <a:noFill/>
-          <a:ln/>
-        </p:spPr>
-        <p:txBody>
-          <a:bodyPr wrap="square" lIns="0" tIns="0" rIns="0" bIns="0" rtlCol="0" anchor="t"/>
-          <a:lstStyle/>
-          <a:p>
-            <a:pPr algn="ctr" indent="0" marL="0">
-              <a:buNone/>
-            </a:pPr>
-            <a:r>
-              <a:rPr lang="en-US" sz="1200" dirty="0">
-                <a:solidFill>
-                  <a:schemeClr val="tx1"/>
-                </a:solidFill>
-              </a:rPr>
-              <a:t>Tests grün</a:t>
-            </a:r>
-            <a:endParaRPr lang="en-US" sz="1200" dirty="0"/>
-          </a:p>
-        </p:txBody>
-      </p:sp>
-      <p:sp>
-        <p:nvSpPr>
-          <p:cNvPr id="7" name="Kennzahl Account, Booking, Konten"/>
-          <p:cNvSpPr/>
-          <p:nvPr/>
-        </p:nvSpPr>
-        <p:spPr>
-          <a:xfrm>
-            <a:off x="3291840" y="1051560"/>
-            <a:ext cx="2560320" cy="1371600"/>
-          </a:xfrm>
-          <a:prstGeom prst="roundRect">
-            <a:avLst>
-              <a:gd name="adj" fmla="val 5333"/>
-            </a:avLst>
-          </a:prstGeom>
-          <a:solidFill>
-            <a:schemeClr val="bg2"/>
-          </a:solidFill>
-          <a:ln w="12700">
-            <a:solidFill>
-              <a:schemeClr val="bg2"/>
-            </a:solidFill>
-            <a:prstDash val="solid"/>
-          </a:ln>
-        </p:spPr>
-      </p:sp>
-      <p:sp>
-        <p:nvSpPr>
-          <p:cNvPr id="8" name="Text 5"/>
-          <p:cNvSpPr txBox="1"/>
-          <p:nvPr/>
-        </p:nvSpPr>
-        <p:spPr>
-          <a:xfrm>
-            <a:off x="3291840" y="1143000"/>
-            <a:ext cx="2560320" cy="777240"/>
-          </a:xfrm>
-          <a:prstGeom prst="rect">
-            <a:avLst/>
-          </a:prstGeom>
-          <a:noFill/>
-          <a:ln/>
-        </p:spPr>
-        <p:txBody>
-          <a:bodyPr wrap="square" lIns="0" tIns="0" rIns="0" bIns="0" rtlCol="0" anchor="ctr"/>
-          <a:lstStyle/>
-          <a:p>
-            <a:pPr algn="ctr" indent="0" marL="0">
-              <a:buNone/>
-            </a:pPr>
-            <a:r>
-              <a:rPr lang="en-US" sz="3600" b="1" dirty="0">
-                <a:solidFill>
-                  <a:schemeClr val="accent1"/>
-                </a:solidFill>
-                <a:latin typeface="Cambria" pitchFamily="34" charset="0"/>
-                <a:ea typeface="Cambria" pitchFamily="34" charset="-122"/>
-                <a:cs typeface="Cambria" pitchFamily="34" charset="-120"/>
-              </a:rPr>
-              <a:t>100 %</a:t>
-            </a:r>
-            <a:endParaRPr lang="en-US" sz="3600" dirty="0"/>
-          </a:p>
-        </p:txBody>
-      </p:sp>
-      <p:sp>
-        <p:nvSpPr>
-          <p:cNvPr id="9" name="Text 6"/>
-          <p:cNvSpPr txBox="1"/>
-          <p:nvPr/>
-        </p:nvSpPr>
-        <p:spPr>
-          <a:xfrm>
-            <a:off x="3383280" y="1920240"/>
-            <a:ext cx="2377440" cy="457200"/>
-          </a:xfrm>
-          <a:prstGeom prst="rect">
-            <a:avLst/>
-          </a:prstGeom>
-          <a:noFill/>
-          <a:ln/>
-        </p:spPr>
-        <p:txBody>
-          <a:bodyPr wrap="square" lIns="0" tIns="0" rIns="0" bIns="0" rtlCol="0" anchor="t"/>
-          <a:lstStyle/>
-          <a:p>
-            <a:pPr algn="ctr" indent="0" marL="0">
-              <a:buNone/>
-            </a:pPr>
-            <a:r>
-              <a:rPr lang="en-US" sz="1200" dirty="0">
-                <a:solidFill>
-                  <a:schemeClr val="tx1"/>
-                </a:solidFill>
-              </a:rPr>
-              <a:t>Account, Booking, Konten</a:t>
-            </a:r>
-            <a:endParaRPr lang="en-US" sz="1200" dirty="0"/>
-          </a:p>
-        </p:txBody>
-      </p:sp>
-      <p:sp>
-        <p:nvSpPr>
-          <p:cNvPr id="10" name="Kennzahl Bank"/>
-          <p:cNvSpPr/>
-          <p:nvPr/>
-        </p:nvSpPr>
-        <p:spPr>
-          <a:xfrm>
-            <a:off x="6126480" y="1051560"/>
-            <a:ext cx="2560320" cy="1371600"/>
-          </a:xfrm>
-          <a:prstGeom prst="roundRect">
-            <a:avLst>
-              <a:gd name="adj" fmla="val 5333"/>
-            </a:avLst>
-          </a:prstGeom>
-          <a:solidFill>
-            <a:schemeClr val="bg2"/>
-          </a:solidFill>
-          <a:ln w="12700">
-            <a:solidFill>
-              <a:schemeClr val="bg2"/>
-            </a:solidFill>
-            <a:prstDash val="solid"/>
-          </a:ln>
-        </p:spPr>
-      </p:sp>
-      <p:sp>
-        <p:nvSpPr>
-          <p:cNvPr id="11" name="Text 8"/>
-          <p:cNvSpPr txBox="1"/>
-          <p:nvPr/>
-        </p:nvSpPr>
-        <p:spPr>
-          <a:xfrm>
-            <a:off x="6126480" y="1143000"/>
-            <a:ext cx="2560320" cy="777240"/>
-          </a:xfrm>
-          <a:prstGeom prst="rect">
-            <a:avLst/>
-          </a:prstGeom>
-          <a:noFill/>
-          <a:ln/>
-        </p:spPr>
-        <p:txBody>
-          <a:bodyPr wrap="square" lIns="0" tIns="0" rIns="0" bIns="0" rtlCol="0" anchor="ctr"/>
-          <a:lstStyle/>
-          <a:p>
-            <a:pPr algn="ctr" indent="0" marL="0">
-              <a:buNone/>
-            </a:pPr>
-            <a:r>
-              <a:rPr lang="en-US" sz="3600" b="1" dirty="0">
-                <a:solidFill>
-                  <a:schemeClr val="accent1"/>
-                </a:solidFill>
-                <a:latin typeface="Cambria" pitchFamily="34" charset="0"/>
-                <a:ea typeface="Cambria" pitchFamily="34" charset="-122"/>
-                <a:cs typeface="Cambria" pitchFamily="34" charset="-120"/>
-              </a:rPr>
-              <a:t>97 %</a:t>
-            </a:r>
-            <a:endParaRPr lang="en-US" sz="3600" dirty="0"/>
-          </a:p>
-        </p:txBody>
-      </p:sp>
-      <p:sp>
-        <p:nvSpPr>
-          <p:cNvPr id="12" name="Text 9"/>
-          <p:cNvSpPr txBox="1"/>
-          <p:nvPr/>
-        </p:nvSpPr>
-        <p:spPr>
-          <a:xfrm>
-            <a:off x="6217920" y="1920240"/>
-            <a:ext cx="2377440" cy="457200"/>
-          </a:xfrm>
-          <a:prstGeom prst="rect">
-            <a:avLst/>
-          </a:prstGeom>
-          <a:noFill/>
-          <a:ln/>
-        </p:spPr>
-        <p:txBody>
-          <a:bodyPr wrap="square" lIns="0" tIns="0" rIns="0" bIns="0" rtlCol="0" anchor="t"/>
-          <a:lstStyle/>
-          <a:p>
-            <a:pPr algn="ctr" indent="0" marL="0">
-              <a:buNone/>
-            </a:pPr>
-            <a:r>
-              <a:rPr lang="en-US" sz="1200" dirty="0">
-                <a:solidFill>
-                  <a:schemeClr val="tx1"/>
-                </a:solidFill>
-              </a:rPr>
-              <a:t>Bank</a:t>
-            </a:r>
-            <a:endParaRPr lang="en-US" sz="1200" dirty="0"/>
-          </a:p>
-        </p:txBody>
-      </p:sp>
-      <p:sp>
-        <p:nvSpPr>
-          <p:cNvPr id="13" name="Code Box"/>
-          <p:cNvSpPr/>
-          <p:nvPr/>
-        </p:nvSpPr>
-        <p:spPr>
-          <a:xfrm>
-            <a:off x="457200" y="2697480"/>
-            <a:ext cx="8229600" cy="1828800"/>
-          </a:xfrm>
-          <a:prstGeom prst="roundRect">
-            <a:avLst>
-              <a:gd name="adj" fmla="val 4000"/>
-            </a:avLst>
-          </a:prstGeom>
-          <a:solidFill>
-            <a:schemeClr val="tx1"/>
-          </a:solidFill>
-          <a:ln w="12700">
-            <a:solidFill>
-              <a:schemeClr val="tx1"/>
-            </a:solidFill>
-            <a:prstDash val="solid"/>
-          </a:ln>
-        </p:spPr>
-      </p:sp>
-      <p:sp>
-        <p:nvSpPr>
-          <p:cNvPr id="14" name="Text 11"/>
-          <p:cNvSpPr txBox="1"/>
-          <p:nvPr/>
-        </p:nvSpPr>
-        <p:spPr>
-          <a:xfrm>
-            <a:off x="640080" y="2807208"/>
-            <a:ext cx="7863840" cy="274320"/>
-          </a:xfrm>
-          <a:prstGeom prst="rect">
-            <a:avLst/>
-          </a:prstGeom>
-          <a:noFill/>
-          <a:ln/>
-        </p:spPr>
-        <p:txBody>
-          <a:bodyPr wrap="square" lIns="0" tIns="0" rIns="0" bIns="0" rtlCol="0" anchor="ctr"/>
-          <a:lstStyle/>
-          <a:p>
-            <a:pPr indent="0" marL="0">
-              <a:buNone/>
-            </a:pPr>
-            <a:r>
-              <a:rPr lang="en-US" sz="1100" b="1" dirty="0">
-                <a:solidFill>
-                  <a:schemeClr val="accent6"/>
-                </a:solidFill>
-              </a:rPr>
-              <a:t>Ausgabe von print() testen</a:t>
-            </a:r>
-            <a:endParaRPr lang="en-US" sz="1100" dirty="0"/>
-          </a:p>
-        </p:txBody>
-      </p:sp>
-      <p:sp>
-        <p:nvSpPr>
-          <p:cNvPr id="15" name="Code"/>
-          <p:cNvSpPr txBox="1"/>
-          <p:nvPr/>
-        </p:nvSpPr>
-        <p:spPr>
-          <a:xfrm>
-            <a:off x="640080" y="3108960"/>
-            <a:ext cx="7863840" cy="1280160"/>
-          </a:xfrm>
-          <a:prstGeom prst="rect">
-            <a:avLst/>
-          </a:prstGeom>
-          <a:noFill/>
-          <a:ln/>
-        </p:spPr>
-        <p:txBody>
-          <a:bodyPr wrap="square" lIns="0" tIns="0" rIns="0" bIns="0" rtlCol="0" anchor="t"/>
-          <a:lstStyle/>
-          <a:p>
-            <a:pPr indent="0" marL="0">
-              <a:buNone/>
-            </a:pPr>
-            <a:r>
-              <a:rPr lang="en-US" sz="1300" dirty="0">
-                <a:solidFill>
-                  <a:schemeClr val="bg1"/>
-                </a:solidFill>
-                <a:latin typeface="Courier New" pitchFamily="34" charset="0"/>
-                <a:ea typeface="Courier New" pitchFamily="34" charset="-122"/>
-                <a:cs typeface="Courier New" pitchFamily="34" charset="-120"/>
-              </a:rPr>
-              <a:t>output = new ByteArrayOutputStream();</a:t>
-            </a:r>
-            <a:endParaRPr lang="en-US" sz="1300" dirty="0"/>
-          </a:p>
-          <a:p>
-            <a:pPr indent="0" marL="0">
-              <a:buNone/>
-            </a:pPr>
-            <a:r>
-              <a:rPr lang="en-US" sz="1300" dirty="0">
-                <a:solidFill>
-                  <a:schemeClr val="bg1"/>
-                </a:solidFill>
-                <a:latin typeface="Courier New" pitchFamily="34" charset="0"/>
-                <a:ea typeface="Courier New" pitchFamily="34" charset="-122"/>
-                <a:cs typeface="Courier New" pitchFamily="34" charset="-120"/>
-              </a:rPr>
-              <a:t>System.setOut(new PrintStream(output));</a:t>
-            </a:r>
-            <a:endParaRPr lang="en-US" sz="1300" dirty="0"/>
-          </a:p>
-          <a:p>
-            <a:pPr indent="0" marL="0">
-              <a:buNone/>
-            </a:pPr>
-            <a:endParaRPr lang="en-US" sz="1300" dirty="0"/>
-          </a:p>
-          <a:p>
-            <a:pPr indent="0" marL="0">
-              <a:buNone/>
-            </a:pPr>
-            <a:r>
-              <a:rPr lang="en-US" sz="1300" dirty="0">
-                <a:solidFill>
-                  <a:schemeClr val="bg1"/>
-                </a:solidFill>
-                <a:latin typeface="Courier New" pitchFamily="34" charset="0"/>
-                <a:ea typeface="Courier New" pitchFamily="34" charset="-122"/>
-                <a:cs typeface="Courier New" pitchFamily="34" charset="-120"/>
-              </a:rPr>
-              <a:t>account.print();</a:t>
-            </a:r>
-            <a:endParaRPr lang="en-US" sz="1300" dirty="0"/>
-          </a:p>
-          <a:p>
-            <a:pPr indent="0" marL="0">
-              <a:buNone/>
-            </a:pPr>
-            <a:r>
-              <a:rPr lang="en-US" sz="1300" dirty="0">
-                <a:solidFill>
-                  <a:schemeClr val="bg1"/>
-                </a:solidFill>
-                <a:latin typeface="Courier New" pitchFamily="34" charset="0"/>
-                <a:ea typeface="Courier New" pitchFamily="34" charset="-122"/>
-                <a:cs typeface="Courier New" pitchFamily="34" charset="-120"/>
-              </a:rPr>
-              <a:t>assertTrue(output.toString().contains("01.01.1970"));</a:t>
-            </a:r>
-            <a:endParaRPr lang="en-US" sz="1300" dirty="0"/>
-          </a:p>
-        </p:txBody>
-      </p:sp>
-      <p:sp>
-        <p:nvSpPr>
-          <p:cNvPr id="25" name="Slide Number Placeholder 0"/>
-          <p:cNvSpPr>
-            <a:spLocks noGrp="1"/>
-          </p:cNvSpPr>
-          <p:nvPr>
-            <p:ph type="sldNum" sz="quarter" idx="4294967295"/>
-          </p:nvPr>
-        </p:nvSpPr>
-        <p:spPr>
-          <a:xfrm>
-            <a:off x="8229600" y="4754880"/>
-            <a:ext cx="457200" cy="228600"/>
-          </a:xfrm>
-          <a:prstGeom prst="rect">
-            <a:avLst/>
-          </a:prstGeom>
-          <a:extLst>
-            <a:ext uri="{C572A759-6A51-4108-AA02-DFA0A04FC94B}">
-              <ma14:wrappingTextBoxFlag xmlns:ma14="http://schemas.microsoft.com/office/mac/drawingml/2011/main" val="0"/>
-            </a:ext>
-          </a:extLst>
-        </p:spPr>
-        <p:txBody>
-          <a:bodyPr/>
-          <a:lstStyle>
-            <a:lvl1pPr>
-              <a:defRPr sz="1000">
-                <a:solidFill>
-                  <a:schemeClr val="accent5"/>
-                </a:solidFill>
-              </a:defRPr>
-            </a:lvl1pPr>
-          </a:lstStyle>
-          <a:p>
-            <a:pPr algn="r"/>
-            <a:fld id="{F7021451-1387-4CA6-816F-3879F97B5CBC}" type="slidenum">
-              <a:rPr b="0" lang="en-US"/>
-              <a:t>6</a:t>
-            </a:fld>
-            <a:endParaRPr lang="en-US"/>
-          </a:p>
-        </p:txBody>
-      </p:sp>
-    </p:spTree>
-  </p:cSld>
-  <p:clrMapOvr>
-    <a:masterClrMapping/>
-  </p:clrMapOvr>
-</p:sld>
-</file>
-
-<file path=ppt/slides/slide7.xml><?xml version="1.0" encoding="utf-8"?>
-<p:sld xmlns:a="http://schemas.openxmlformats.org/drawingml/2006/main" xmlns:r="http://schemas.openxmlformats.org/officeDocument/2006/relationships" xmlns:p="http://schemas.openxmlformats.org/presentationml/2006/main">
-  <p:cSld name="Slide 7">
     <p:spTree>
       <p:nvGrpSpPr>
         <p:cNvPr id="1" name=""/>

</xml_diff>